<commit_message>
Add condensed report and 12-slide video deck
Add report_simple.tex, a shorter plain-language version of the report,
and expand the video presentation to 12 slides (~10 min) with the title
slide filled in (Course Code DA 379) and links pointing at iitgF/T9.

Co-Authored-By: Claude Opus 4.8 <noreply@anthropic.com>
</commit_message>
<xml_diff>
--- a/Project_Video_Presentation.pptx
+++ b/Project_Video_Presentation.pptx
@@ -16,6 +16,10 @@
     <p:sldId id="262" r:id="rId15"/>
     <p:sldId id="263" r:id="rId16"/>
     <p:sldId id="264" r:id="rId17"/>
+    <p:sldId id="265" r:id="rId18"/>
+    <p:sldId id="266" r:id="rId19"/>
+    <p:sldId id="267" r:id="rId20"/>
+    <p:sldId id="268" r:id="rId21"/>
   </p:sldIdLst>
   <p:sldSz cx="12192000" cy="6858000"/>
   <p:notesSz cx="6858000" cy="9144000"/>
@@ -4648,7 +4652,7 @@
                       <a:srgbClr val="FFFFFF"/>
                     </a:solidFill>
                   </a:rPr>
-                  <a:t>[Course Code: to be filled]</a:t>
+                  <a:t>DA 379</a:t>
                 </a:r>
                 <a:endParaRPr lang="en-US" dirty="0"/>
               </a:p>
@@ -4802,7 +4806,7 @@
 </p:sld>
 </file>
 
-<file path=ppt/slides/slide2.xml><?xml version="1.0" encoding="utf-8"?>
+<file path=ppt/slides/slide10.xml><?xml version="1.0" encoding="utf-8"?>
 <p:sld xmlns:a="http://schemas.openxmlformats.org/drawingml/2006/main" xmlns:p="http://schemas.openxmlformats.org/presentationml/2006/main" xmlns:r="http://schemas.openxmlformats.org/officeDocument/2006/relationships">
   <p:cSld>
     <p:spTree>
@@ -4834,7 +4838,6 @@
           </a:bodyPr>
           <a:lstStyle/>
           <a:p>
-            <a:pPr algn="l"/>
             <a:r>
               <a:rPr sz="3000" b="1" i="0">
                 <a:solidFill>
@@ -4842,7 +4845,7 @@
                 </a:solidFill>
                 <a:latin typeface="Calibri"/>
               </a:rPr>
-              <a:t>The Problem: One-Day-Ahead Volatility</a:t>
+              <a:t>Is the Winner Really Better?</a:t>
             </a:r>
           </a:p>
         </p:txBody>
@@ -4876,7 +4879,7 @@
                 </a:solidFill>
                 <a:latin typeface="Calibri"/>
               </a:rPr>
-              <a:t>Why forecast volatility, and why is it hard?</a:t>
+              <a:t>The best model vs the best baseline</a:t>
             </a:r>
           </a:p>
         </p:txBody>
@@ -4889,8 +4892,8 @@
         </p:nvSpPr>
         <p:spPr>
           <a:xfrm>
-            <a:off x="502920" y="1737360"/>
-            <a:ext cx="5486400" cy="4206240"/>
+            <a:off x="502920" y="1600200"/>
+            <a:ext cx="5486400" cy="2103120"/>
           </a:xfrm>
           <a:prstGeom prst="rect">
             <a:avLst/>
@@ -4915,7 +4918,7 @@
                 </a:solidFill>
                 <a:latin typeface="Calibri"/>
               </a:rPr>
-              <a:t>Goal:  </a:t>
+              <a:t>GARCH(1,1)  </a:t>
             </a:r>
             <a:r>
               <a:rPr sz="1500" b="0" i="0">
@@ -4924,7 +4927,7 @@
                 </a:solidFill>
                 <a:latin typeface="Calibri"/>
               </a:rPr>
-              <a:t>predict tomorrow's return variance for the S&amp;P 500, using only information available today.</a:t>
+              <a:t>gives the lowest QLIKE of all eight models.</a:t>
             </a:r>
           </a:p>
           <a:p>
@@ -4940,7 +4943,7 @@
                 </a:solidFill>
                 <a:latin typeface="Calibri"/>
               </a:rPr>
-              <a:t>Why it matters:  </a:t>
+              <a:t>But  </a:t>
             </a:r>
             <a:r>
               <a:rPr sz="1500" b="0" i="0">
@@ -4949,7 +4952,7 @@
                 </a:solidFill>
                 <a:latin typeface="Calibri"/>
               </a:rPr>
-              <a:t>volatility drives option pricing, value-at-risk, margins and position sizing.</a:t>
+              <a:t>the top three GARCH-family models are statistically tied.</a:t>
             </a:r>
           </a:p>
           <a:p>
@@ -4965,7 +4968,7 @@
                 </a:solidFill>
                 <a:latin typeface="Calibri"/>
               </a:rPr>
-              <a:t>The asymmetry:  </a:t>
+              <a:t>Diebold–Mariano:  </a:t>
             </a:r>
             <a:r>
               <a:rPr sz="1500" b="0" i="0">
@@ -4974,64 +4977,196 @@
                 </a:solidFill>
                 <a:latin typeface="Calibri"/>
               </a:rPr>
-              <a:t>the direction of returns is unpredictable, but their magnitude is strongly persistent.</a:t>
-            </a:r>
-          </a:p>
-          <a:p>
-            <a:pPr algn="l">
-              <a:spcAft>
-                <a:spcPts val="1000"/>
-              </a:spcAft>
-            </a:pPr>
-            <a:r>
-              <a:rPr sz="1500" b="1" i="0">
-                <a:solidFill>
-                  <a:srgbClr val="C8960C"/>
-                </a:solidFill>
-                <a:latin typeface="Calibri"/>
-              </a:rPr>
-              <a:t>The catch:  </a:t>
-            </a:r>
-            <a:r>
-              <a:rPr sz="1500" b="0" i="0">
-                <a:solidFill>
-                  <a:srgbClr val="2B2B2B"/>
-                </a:solidFill>
-                <a:latin typeface="Calibri"/>
-              </a:rPr>
-              <a:t>true volatility is never observed. We score against the noisy squared-return proxy.</a:t>
-            </a:r>
-          </a:p>
-          <a:p>
-            <a:pPr algn="l">
-              <a:spcAft>
-                <a:spcPts val="1000"/>
-              </a:spcAft>
-            </a:pPr>
-            <a:r>
-              <a:rPr sz="1500" b="1" i="0">
-                <a:solidFill>
-                  <a:srgbClr val="C8960C"/>
-                </a:solidFill>
-                <a:latin typeface="Calibri"/>
-              </a:rPr>
-              <a:t>The question:  </a:t>
-            </a:r>
-            <a:r>
-              <a:rPr sz="1500" b="0" i="0">
-                <a:solidFill>
-                  <a:srgbClr val="2B2B2B"/>
-                </a:solidFill>
-                <a:latin typeface="Calibri"/>
-              </a:rPr>
-              <a:t>can ML (XGBoost) and deep learning (LSTM) beat classical GARCH-type baselines?</a:t>
+              <a:t>GARCH(1,1) vs EGARCH(1,1) gives p = 0.87, not significant.</a:t>
+            </a:r>
+          </a:p>
+        </p:txBody>
+      </p:sp>
+      <p:sp>
+        <p:nvSpPr>
+          <p:cNvPr id="5" name="Rounded Rectangle 4"/>
+          <p:cNvSpPr/>
+          <p:nvPr/>
+        </p:nvSpPr>
+        <p:spPr>
+          <a:xfrm>
+            <a:off x="502920" y="3931920"/>
+            <a:ext cx="2743200" cy="1371600"/>
+          </a:xfrm>
+          <a:prstGeom prst="roundRect">
+            <a:avLst/>
+          </a:prstGeom>
+          <a:solidFill>
+            <a:srgbClr val="F7EFDD"/>
+          </a:solidFill>
+          <a:ln>
+            <a:noFill/>
+          </a:ln>
+          <a:effectLst/>
+        </p:spPr>
+        <p:style>
+          <a:lnRef idx="1">
+            <a:schemeClr val="accent1"/>
+          </a:lnRef>
+          <a:fillRef idx="3">
+            <a:schemeClr val="accent1"/>
+          </a:fillRef>
+          <a:effectRef idx="2">
+            <a:schemeClr val="accent1"/>
+          </a:effectRef>
+          <a:fontRef idx="minor">
+            <a:schemeClr val="lt1"/>
+          </a:fontRef>
+        </p:style>
+        <p:txBody>
+          <a:bodyPr rtlCol="0" anchor="ctr"/>
+          <a:lstStyle/>
+          <a:p>
+            <a:pPr algn="ctr"/>
+          </a:p>
+        </p:txBody>
+      </p:sp>
+      <p:sp>
+        <p:nvSpPr>
+          <p:cNvPr id="6" name="TextBox 5"/>
+          <p:cNvSpPr txBox="1"/>
+          <p:nvPr/>
+        </p:nvSpPr>
+        <p:spPr>
+          <a:xfrm>
+            <a:off x="502920" y="4096512"/>
+            <a:ext cx="2743200" cy="1051560"/>
+          </a:xfrm>
+          <a:prstGeom prst="rect">
+            <a:avLst/>
+          </a:prstGeom>
+          <a:noFill/>
+        </p:spPr>
+        <p:txBody>
+          <a:bodyPr wrap="square" anchor="ctr" lIns="0" rIns="0" tIns="0" bIns="0">
+            <a:spAutoFit/>
+          </a:bodyPr>
+          <a:lstStyle/>
+          <a:p>
+            <a:pPr algn="ctr"/>
+            <a:r>
+              <a:rPr sz="2400" b="1" i="0">
+                <a:solidFill>
+                  <a:srgbClr val="003366"/>
+                </a:solidFill>
+                <a:latin typeface="Calibri"/>
+              </a:rPr>
+              <a:t>QLIKE 1.488</a:t>
+            </a:r>
+          </a:p>
+          <a:p>
+            <a:pPr algn="ctr"/>
+            <a:r>
+              <a:rPr sz="1200" b="0" i="0">
+                <a:solidFill>
+                  <a:srgbClr val="555555"/>
+                </a:solidFill>
+                <a:latin typeface="Calibri"/>
+              </a:rPr>
+              <a:t>GARCH(1,1), best model</a:t>
+            </a:r>
+          </a:p>
+        </p:txBody>
+      </p:sp>
+      <p:sp>
+        <p:nvSpPr>
+          <p:cNvPr id="7" name="Rounded Rectangle 6"/>
+          <p:cNvSpPr/>
+          <p:nvPr/>
+        </p:nvSpPr>
+        <p:spPr>
+          <a:xfrm>
+            <a:off x="3520440" y="3931920"/>
+            <a:ext cx="2743200" cy="1371600"/>
+          </a:xfrm>
+          <a:prstGeom prst="roundRect">
+            <a:avLst/>
+          </a:prstGeom>
+          <a:solidFill>
+            <a:srgbClr val="F7EFDD"/>
+          </a:solidFill>
+          <a:ln>
+            <a:noFill/>
+          </a:ln>
+          <a:effectLst/>
+        </p:spPr>
+        <p:style>
+          <a:lnRef idx="1">
+            <a:schemeClr val="accent1"/>
+          </a:lnRef>
+          <a:fillRef idx="3">
+            <a:schemeClr val="accent1"/>
+          </a:fillRef>
+          <a:effectRef idx="2">
+            <a:schemeClr val="accent1"/>
+          </a:effectRef>
+          <a:fontRef idx="minor">
+            <a:schemeClr val="lt1"/>
+          </a:fontRef>
+        </p:style>
+        <p:txBody>
+          <a:bodyPr rtlCol="0" anchor="ctr"/>
+          <a:lstStyle/>
+          <a:p>
+            <a:pPr algn="ctr"/>
+          </a:p>
+        </p:txBody>
+      </p:sp>
+      <p:sp>
+        <p:nvSpPr>
+          <p:cNvPr id="8" name="TextBox 7"/>
+          <p:cNvSpPr txBox="1"/>
+          <p:nvPr/>
+        </p:nvSpPr>
+        <p:spPr>
+          <a:xfrm>
+            <a:off x="3520440" y="4096512"/>
+            <a:ext cx="2743200" cy="1051560"/>
+          </a:xfrm>
+          <a:prstGeom prst="rect">
+            <a:avLst/>
+          </a:prstGeom>
+          <a:noFill/>
+        </p:spPr>
+        <p:txBody>
+          <a:bodyPr wrap="square" anchor="ctr" lIns="0" rIns="0" tIns="0" bIns="0">
+            <a:spAutoFit/>
+          </a:bodyPr>
+          <a:lstStyle/>
+          <a:p>
+            <a:pPr algn="ctr"/>
+            <a:r>
+              <a:rPr sz="2400" b="1" i="0">
+                <a:solidFill>
+                  <a:srgbClr val="003366"/>
+                </a:solidFill>
+                <a:latin typeface="Calibri"/>
+              </a:rPr>
+              <a:t>p = 0.87</a:t>
+            </a:r>
+          </a:p>
+          <a:p>
+            <a:pPr algn="ctr"/>
+            <a:r>
+              <a:rPr sz="1200" b="0" i="0">
+                <a:solidFill>
+                  <a:srgbClr val="555555"/>
+                </a:solidFill>
+                <a:latin typeface="Calibri"/>
+              </a:rPr>
+              <a:t>GARCH vs EGARCH: not significant</a:t>
             </a:r>
           </a:p>
         </p:txBody>
       </p:sp>
       <p:pic>
         <p:nvPicPr>
-          <p:cNvPr id="5" name="Picture 4" descr="fig_correlogram.png"/>
+          <p:cNvPr id="9" name="Picture 8" descr="fig_best_vs_realized.png"/>
           <p:cNvPicPr>
             <a:picLocks noChangeAspect="1"/>
           </p:cNvPicPr>
@@ -5045,24 +5180,42 @@
         </p:blipFill>
         <p:spPr>
           <a:xfrm>
-            <a:off x="6263640" y="2589928"/>
-            <a:ext cx="5394960" cy="1769583"/>
+            <a:off x="6172200" y="2834640"/>
+            <a:ext cx="5486400" cy="1828800"/>
           </a:xfrm>
           <a:prstGeom prst="rect">
             <a:avLst/>
           </a:prstGeom>
         </p:spPr>
       </p:pic>
-      <p:sp>
-        <p:nvSpPr>
-          <p:cNvPr id="6" name="TextBox 5"/>
+    </p:spTree>
+  </p:cSld>
+  <p:clrMapOvr>
+    <a:masterClrMapping/>
+  </p:clrMapOvr>
+</p:sld>
+</file>
+
+<file path=ppt/slides/slide11.xml><?xml version="1.0" encoding="utf-8"?>
+<p:sld xmlns:a="http://schemas.openxmlformats.org/drawingml/2006/main" xmlns:p="http://schemas.openxmlformats.org/presentationml/2006/main" xmlns:r="http://schemas.openxmlformats.org/officeDocument/2006/relationships">
+  <p:cSld>
+    <p:spTree>
+      <p:nvGrpSpPr>
+        <p:cNvPr id="1" name=""/>
+        <p:cNvGrpSpPr/>
+        <p:nvPr/>
+      </p:nvGrpSpPr>
+      <p:grpSpPr/>
+      <p:sp>
+        <p:nvSpPr>
+          <p:cNvPr id="2" name="TextBox 1"/>
           <p:cNvSpPr txBox="1"/>
           <p:nvPr/>
         </p:nvSpPr>
         <p:spPr>
           <a:xfrm>
-            <a:off x="6263640" y="5257800"/>
-            <a:ext cx="5394960" cy="640080"/>
+            <a:off x="502920" y="384048"/>
+            <a:ext cx="11155680" cy="914400"/>
           </a:xfrm>
           <a:prstGeom prst="rect">
             <a:avLst/>
@@ -5076,13 +5229,728 @@
           <a:lstStyle/>
           <a:p>
             <a:r>
-              <a:rPr sz="1100" b="0" i="1">
-                <a:solidFill>
-                  <a:srgbClr val="555555"/>
-                </a:solidFill>
-                <a:latin typeface="Calibri"/>
-              </a:rPr>
-              <a:t>Returns show no autocorrelation; absolute returns do — volatility clusters. That persistence is the only signal any model exploits.</a:t>
+              <a:rPr sz="3000" b="1" i="0">
+                <a:solidFill>
+                  <a:srgbClr val="003366"/>
+                </a:solidFill>
+                <a:latin typeface="Calibri"/>
+              </a:rPr>
+              <a:t>Why Is GARCH So Hard to Beat?</a:t>
+            </a:r>
+          </a:p>
+        </p:txBody>
+      </p:sp>
+      <p:sp>
+        <p:nvSpPr>
+          <p:cNvPr id="3" name="TextBox 2"/>
+          <p:cNvSpPr txBox="1"/>
+          <p:nvPr/>
+        </p:nvSpPr>
+        <p:spPr>
+          <a:xfrm>
+            <a:off x="502920" y="1737360"/>
+            <a:ext cx="11155680" cy="4206240"/>
+          </a:xfrm>
+          <a:prstGeom prst="rect">
+            <a:avLst/>
+          </a:prstGeom>
+          <a:noFill/>
+        </p:spPr>
+        <p:txBody>
+          <a:bodyPr wrap="square" anchor="t" lIns="0" rIns="0" tIns="0" bIns="0">
+            <a:spAutoFit/>
+          </a:bodyPr>
+          <a:lstStyle/>
+          <a:p>
+            <a:pPr algn="l">
+              <a:spcAft>
+                <a:spcPts val="1300"/>
+              </a:spcAft>
+            </a:pPr>
+            <a:r>
+              <a:rPr sz="1600" b="1" i="0">
+                <a:solidFill>
+                  <a:srgbClr val="C8960C"/>
+                </a:solidFill>
+                <a:latin typeface="Calibri"/>
+              </a:rPr>
+              <a:t>Signal shape:  </a:t>
+            </a:r>
+            <a:r>
+              <a:rPr sz="1600" b="0" i="0">
+                <a:solidFill>
+                  <a:srgbClr val="2B2B2B"/>
+                </a:solidFill>
+                <a:latin typeface="Calibri"/>
+              </a:rPr>
+              <a:t>the exploitable signal is one-dimensional, and GARCH is built exactly for it with three parameters.</a:t>
+            </a:r>
+          </a:p>
+          <a:p>
+            <a:pPr algn="l">
+              <a:spcAft>
+                <a:spcPts val="1300"/>
+              </a:spcAft>
+            </a:pPr>
+            <a:r>
+              <a:rPr sz="1600" b="1" i="0">
+                <a:solidFill>
+                  <a:srgbClr val="C8960C"/>
+                </a:solidFill>
+                <a:latin typeface="Calibri"/>
+              </a:rPr>
+              <a:t>Right objective:  </a:t>
+            </a:r>
+            <a:r>
+              <a:rPr sz="1600" b="0" i="0">
+                <a:solidFill>
+                  <a:srgbClr val="2B2B2B"/>
+                </a:solidFill>
+                <a:latin typeface="Calibri"/>
+              </a:rPr>
+              <a:t>GARCH is fit by maximum likelihood on variance; the learned models train on a smoother substitute target.</a:t>
+            </a:r>
+          </a:p>
+          <a:p>
+            <a:pPr algn="l">
+              <a:spcAft>
+                <a:spcPts val="1300"/>
+              </a:spcAft>
+            </a:pPr>
+            <a:r>
+              <a:rPr sz="1600" b="1" i="0">
+                <a:solidFill>
+                  <a:srgbClr val="C8960C"/>
+                </a:solidFill>
+                <a:latin typeface="Calibri"/>
+              </a:rPr>
+              <a:t>Small data:  </a:t>
+            </a:r>
+            <a:r>
+              <a:rPr sz="1600" b="0" i="0">
+                <a:solidFill>
+                  <a:srgbClr val="2B2B2B"/>
+                </a:solidFill>
+                <a:latin typeface="Calibri"/>
+              </a:rPr>
+              <a:t>roughly 3,000 noisy training days favours simple models over neural networks.</a:t>
+            </a:r>
+          </a:p>
+          <a:p>
+            <a:pPr algn="l">
+              <a:spcAft>
+                <a:spcPts val="1300"/>
+              </a:spcAft>
+            </a:pPr>
+            <a:r>
+              <a:rPr sz="1600" b="1" i="0">
+                <a:solidFill>
+                  <a:srgbClr val="C8960C"/>
+                </a:solidFill>
+                <a:latin typeface="Calibri"/>
+              </a:rPr>
+              <a:t>QLIKE asymmetry:  </a:t>
+            </a:r>
+            <a:r>
+              <a:rPr sz="1600" b="0" i="0">
+                <a:solidFill>
+                  <a:srgbClr val="2B2B2B"/>
+                </a:solidFill>
+                <a:latin typeface="Calibri"/>
+              </a:rPr>
+              <a:t>it rewards fast reactions to spikes, and GARCH reacts the very next day.</a:t>
+            </a:r>
+          </a:p>
+          <a:p>
+            <a:pPr algn="l">
+              <a:spcAft>
+                <a:spcPts val="1300"/>
+              </a:spcAft>
+            </a:pPr>
+            <a:r>
+              <a:rPr sz="1600" b="1" i="0">
+                <a:solidFill>
+                  <a:srgbClr val="C8960C"/>
+                </a:solidFill>
+                <a:latin typeface="Calibri"/>
+              </a:rPr>
+              <a:t>Limitations:  </a:t>
+            </a:r>
+            <a:r>
+              <a:rPr sz="1600" b="0" i="0">
+                <a:solidFill>
+                  <a:srgbClr val="2B2B2B"/>
+                </a:solidFill>
+                <a:latin typeface="Calibri"/>
+              </a:rPr>
+              <a:t>single asset and window, a noisy proxy, and deliberately modest hyperparameter tuning.</a:t>
+            </a:r>
+          </a:p>
+        </p:txBody>
+      </p:sp>
+    </p:spTree>
+  </p:cSld>
+  <p:clrMapOvr>
+    <a:masterClrMapping/>
+  </p:clrMapOvr>
+</p:sld>
+</file>
+
+<file path=ppt/slides/slide12.xml><?xml version="1.0" encoding="utf-8"?>
+<p:sld xmlns:a="http://schemas.openxmlformats.org/drawingml/2006/main" xmlns:p="http://schemas.openxmlformats.org/presentationml/2006/main" xmlns:r="http://schemas.openxmlformats.org/officeDocument/2006/relationships">
+  <p:cSld>
+    <p:spTree>
+      <p:nvGrpSpPr>
+        <p:cNvPr id="1" name=""/>
+        <p:cNvGrpSpPr/>
+        <p:nvPr/>
+      </p:nvGrpSpPr>
+      <p:grpSpPr/>
+      <p:sp>
+        <p:nvSpPr>
+          <p:cNvPr id="2" name="TextBox 1"/>
+          <p:cNvSpPr txBox="1"/>
+          <p:nvPr/>
+        </p:nvSpPr>
+        <p:spPr>
+          <a:xfrm>
+            <a:off x="502920" y="384048"/>
+            <a:ext cx="11155680" cy="914400"/>
+          </a:xfrm>
+          <a:prstGeom prst="rect">
+            <a:avLst/>
+          </a:prstGeom>
+          <a:noFill/>
+        </p:spPr>
+        <p:txBody>
+          <a:bodyPr wrap="square" anchor="t" lIns="0" rIns="0" tIns="0" bIns="0">
+            <a:spAutoFit/>
+          </a:bodyPr>
+          <a:lstStyle/>
+          <a:p>
+            <a:r>
+              <a:rPr sz="3000" b="1" i="0">
+                <a:solidFill>
+                  <a:srgbClr val="003366"/>
+                </a:solidFill>
+                <a:latin typeface="Calibri"/>
+              </a:rPr>
+              <a:t>Conclusion &amp; Takeaways</a:t>
+            </a:r>
+          </a:p>
+        </p:txBody>
+      </p:sp>
+      <p:sp>
+        <p:nvSpPr>
+          <p:cNvPr id="3" name="TextBox 2"/>
+          <p:cNvSpPr txBox="1"/>
+          <p:nvPr/>
+        </p:nvSpPr>
+        <p:spPr>
+          <a:xfrm>
+            <a:off x="502920" y="1645920"/>
+            <a:ext cx="6583680" cy="4206240"/>
+          </a:xfrm>
+          <a:prstGeom prst="rect">
+            <a:avLst/>
+          </a:prstGeom>
+          <a:noFill/>
+        </p:spPr>
+        <p:txBody>
+          <a:bodyPr wrap="square" anchor="t" lIns="0" rIns="0" tIns="0" bIns="0">
+            <a:spAutoFit/>
+          </a:bodyPr>
+          <a:lstStyle/>
+          <a:p>
+            <a:pPr algn="l">
+              <a:spcAft>
+                <a:spcPts val="1200"/>
+              </a:spcAft>
+            </a:pPr>
+            <a:r>
+              <a:rPr sz="1600" b="1" i="0">
+                <a:solidFill>
+                  <a:srgbClr val="C8960C"/>
+                </a:solidFill>
+                <a:latin typeface="Calibri"/>
+              </a:rPr>
+              <a:t>Answer:  </a:t>
+            </a:r>
+            <a:r>
+              <a:rPr sz="1600" b="0" i="0">
+                <a:solidFill>
+                  <a:srgbClr val="2B2B2B"/>
+                </a:solidFill>
+                <a:latin typeface="Calibri"/>
+              </a:rPr>
+              <a:t>no. A monthly-refit GARCH(1,1) gives the best QLIKE; no learned model beats the GARCH family where it matters.</a:t>
+            </a:r>
+          </a:p>
+          <a:p>
+            <a:pPr algn="l">
+              <a:spcAft>
+                <a:spcPts val="1200"/>
+              </a:spcAft>
+            </a:pPr>
+            <a:r>
+              <a:rPr sz="1600" b="1" i="0">
+                <a:solidFill>
+                  <a:srgbClr val="C8960C"/>
+                </a:solidFill>
+                <a:latin typeface="Calibri"/>
+              </a:rPr>
+              <a:t>Nuance:  </a:t>
+            </a:r>
+            <a:r>
+              <a:rPr sz="1600" b="0" i="0">
+                <a:solidFill>
+                  <a:srgbClr val="2B2B2B"/>
+                </a:solidFill>
+                <a:latin typeface="Calibri"/>
+              </a:rPr>
+              <a:t>XGBoost wins RMSE and MAE. The learned models are competitive, just beaten on the risk-relevant metric.</a:t>
+            </a:r>
+          </a:p>
+          <a:p>
+            <a:pPr algn="l">
+              <a:spcAft>
+                <a:spcPts val="1200"/>
+              </a:spcAft>
+            </a:pPr>
+            <a:r>
+              <a:rPr sz="1600" b="1" i="0">
+                <a:solidFill>
+                  <a:srgbClr val="C8960C"/>
+                </a:solidFill>
+                <a:latin typeface="Calibri"/>
+              </a:rPr>
+              <a:t>Main lesson:  </a:t>
+            </a:r>
+            <a:r>
+              <a:rPr sz="1600" b="0" i="0">
+                <a:solidFill>
+                  <a:srgbClr val="2B2B2B"/>
+                </a:solidFill>
+                <a:latin typeface="Calibri"/>
+              </a:rPr>
+              <a:t>a leak-free walk-forward harness and the choice of metric matter more than model complexity.</a:t>
+            </a:r>
+          </a:p>
+          <a:p>
+            <a:pPr algn="l">
+              <a:spcAft>
+                <a:spcPts val="1200"/>
+              </a:spcAft>
+            </a:pPr>
+            <a:r>
+              <a:rPr sz="1600" b="1" i="0">
+                <a:solidFill>
+                  <a:srgbClr val="C8960C"/>
+                </a:solidFill>
+                <a:latin typeface="Calibri"/>
+              </a:rPr>
+              <a:t>Future work:  </a:t>
+            </a:r>
+            <a:r>
+              <a:rPr sz="1600" b="0" i="0">
+                <a:solidFill>
+                  <a:srgbClr val="2B2B2B"/>
+                </a:solidFill>
+                <a:latin typeface="Calibri"/>
+              </a:rPr>
+              <a:t>intraday realized variance, extra inputs like the VIX, and multi-asset training.</a:t>
+            </a:r>
+          </a:p>
+        </p:txBody>
+      </p:sp>
+      <p:sp>
+        <p:nvSpPr>
+          <p:cNvPr id="4" name="Rounded Rectangle 3"/>
+          <p:cNvSpPr/>
+          <p:nvPr/>
+        </p:nvSpPr>
+        <p:spPr>
+          <a:xfrm>
+            <a:off x="7360920" y="1828800"/>
+            <a:ext cx="4251960" cy="2103120"/>
+          </a:xfrm>
+          <a:prstGeom prst="roundRect">
+            <a:avLst/>
+          </a:prstGeom>
+          <a:solidFill>
+            <a:srgbClr val="ECF1F6"/>
+          </a:solidFill>
+          <a:ln>
+            <a:noFill/>
+          </a:ln>
+          <a:effectLst/>
+        </p:spPr>
+        <p:style>
+          <a:lnRef idx="1">
+            <a:schemeClr val="accent1"/>
+          </a:lnRef>
+          <a:fillRef idx="3">
+            <a:schemeClr val="accent1"/>
+          </a:fillRef>
+          <a:effectRef idx="2">
+            <a:schemeClr val="accent1"/>
+          </a:effectRef>
+          <a:fontRef idx="minor">
+            <a:schemeClr val="lt1"/>
+          </a:fontRef>
+        </p:style>
+        <p:txBody>
+          <a:bodyPr rtlCol="0" anchor="ctr"/>
+          <a:lstStyle/>
+          <a:p>
+            <a:pPr algn="ctr"/>
+          </a:p>
+        </p:txBody>
+      </p:sp>
+      <p:sp>
+        <p:nvSpPr>
+          <p:cNvPr id="5" name="TextBox 4"/>
+          <p:cNvSpPr txBox="1"/>
+          <p:nvPr/>
+        </p:nvSpPr>
+        <p:spPr>
+          <a:xfrm>
+            <a:off x="7589520" y="2057400"/>
+            <a:ext cx="3840480" cy="1737360"/>
+          </a:xfrm>
+          <a:prstGeom prst="rect">
+            <a:avLst/>
+          </a:prstGeom>
+          <a:noFill/>
+        </p:spPr>
+        <p:txBody>
+          <a:bodyPr wrap="square" anchor="t" lIns="0" rIns="0" tIns="0" bIns="0">
+            <a:spAutoFit/>
+          </a:bodyPr>
+          <a:lstStyle/>
+          <a:p>
+            <a:pPr>
+              <a:spcAft>
+                <a:spcPts val="800"/>
+              </a:spcAft>
+            </a:pPr>
+            <a:r>
+              <a:rPr sz="1600" b="1" i="0">
+                <a:solidFill>
+                  <a:srgbClr val="003366"/>
+                </a:solidFill>
+                <a:latin typeface="Calibri"/>
+              </a:rPr>
+              <a:t>Project artifacts</a:t>
+            </a:r>
+          </a:p>
+          <a:p>
+            <a:pPr>
+              <a:spcAft>
+                <a:spcPts val="600"/>
+              </a:spcAft>
+            </a:pPr>
+            <a:r>
+              <a:rPr sz="1300" b="1" i="0">
+                <a:solidFill>
+                  <a:srgbClr val="C8960C"/>
+                </a:solidFill>
+                <a:latin typeface="Calibri"/>
+              </a:rPr>
+              <a:t>Code: </a:t>
+            </a:r>
+            <a:r>
+              <a:rPr sz="1300" b="0" i="0">
+                <a:solidFill>
+                  <a:srgbClr val="2B2B2B"/>
+                </a:solidFill>
+                <a:latin typeface="Calibri"/>
+              </a:rPr>
+              <a:t>github.com/iitgF/T9</a:t>
+            </a:r>
+          </a:p>
+          <a:p>
+            <a:pPr>
+              <a:spcAft>
+                <a:spcPts val="600"/>
+              </a:spcAft>
+            </a:pPr>
+            <a:r>
+              <a:rPr sz="1300" b="1" i="0">
+                <a:solidFill>
+                  <a:srgbClr val="C8960C"/>
+                </a:solidFill>
+                <a:latin typeface="Calibri"/>
+              </a:rPr>
+              <a:t>Report: </a:t>
+            </a:r>
+            <a:r>
+              <a:rPr sz="1300" b="0" i="0">
+                <a:solidFill>
+                  <a:srgbClr val="2B2B2B"/>
+                </a:solidFill>
+                <a:latin typeface="Calibri"/>
+              </a:rPr>
+              <a:t>LaTeX (Overleaf)</a:t>
+            </a:r>
+          </a:p>
+          <a:p>
+            <a:pPr>
+              <a:spcAft>
+                <a:spcPts val="600"/>
+              </a:spcAft>
+            </a:pPr>
+            <a:r>
+              <a:rPr sz="1300" b="1" i="0">
+                <a:solidFill>
+                  <a:srgbClr val="C8960C"/>
+                </a:solidFill>
+                <a:latin typeface="Calibri"/>
+              </a:rPr>
+              <a:t>Notebook: </a:t>
+            </a:r>
+            <a:r>
+              <a:rPr sz="1300" b="0" i="0">
+                <a:solidFill>
+                  <a:srgbClr val="2B2B2B"/>
+                </a:solidFill>
+                <a:latin typeface="Calibri"/>
+              </a:rPr>
+              <a:t>consolidated, runs end-to-end</a:t>
+            </a:r>
+          </a:p>
+        </p:txBody>
+      </p:sp>
+    </p:spTree>
+  </p:cSld>
+  <p:clrMapOvr>
+    <a:masterClrMapping/>
+  </p:clrMapOvr>
+</p:sld>
+</file>
+
+<file path=ppt/slides/slide2.xml><?xml version="1.0" encoding="utf-8"?>
+<p:sld xmlns:a="http://schemas.openxmlformats.org/drawingml/2006/main" xmlns:p="http://schemas.openxmlformats.org/presentationml/2006/main" xmlns:r="http://schemas.openxmlformats.org/officeDocument/2006/relationships">
+  <p:cSld>
+    <p:spTree>
+      <p:nvGrpSpPr>
+        <p:cNvPr id="1" name=""/>
+        <p:cNvGrpSpPr/>
+        <p:nvPr/>
+      </p:nvGrpSpPr>
+      <p:grpSpPr/>
+      <p:sp>
+        <p:nvSpPr>
+          <p:cNvPr id="2" name="TextBox 1"/>
+          <p:cNvSpPr txBox="1"/>
+          <p:nvPr/>
+        </p:nvSpPr>
+        <p:spPr>
+          <a:xfrm>
+            <a:off x="502920" y="384048"/>
+            <a:ext cx="11155680" cy="914400"/>
+          </a:xfrm>
+          <a:prstGeom prst="rect">
+            <a:avLst/>
+          </a:prstGeom>
+          <a:noFill/>
+        </p:spPr>
+        <p:txBody>
+          <a:bodyPr wrap="square" anchor="t" lIns="0" rIns="0" tIns="0" bIns="0">
+            <a:spAutoFit/>
+          </a:bodyPr>
+          <a:lstStyle/>
+          <a:p>
+            <a:r>
+              <a:rPr sz="3000" b="1" i="0">
+                <a:solidFill>
+                  <a:srgbClr val="003366"/>
+                </a:solidFill>
+                <a:latin typeface="Calibri"/>
+              </a:rPr>
+              <a:t>Introduction</a:t>
+            </a:r>
+          </a:p>
+        </p:txBody>
+      </p:sp>
+      <p:sp>
+        <p:nvSpPr>
+          <p:cNvPr id="3" name="TextBox 2"/>
+          <p:cNvSpPr txBox="1"/>
+          <p:nvPr/>
+        </p:nvSpPr>
+        <p:spPr>
+          <a:xfrm>
+            <a:off x="502920" y="1078992"/>
+            <a:ext cx="11155680" cy="457200"/>
+          </a:xfrm>
+          <a:prstGeom prst="rect">
+            <a:avLst/>
+          </a:prstGeom>
+          <a:noFill/>
+        </p:spPr>
+        <p:txBody>
+          <a:bodyPr wrap="square" anchor="t" lIns="0" rIns="0" tIns="0" bIns="0">
+            <a:spAutoFit/>
+          </a:bodyPr>
+          <a:lstStyle/>
+          <a:p>
+            <a:r>
+              <a:rPr sz="1500" b="1" i="0">
+                <a:solidFill>
+                  <a:srgbClr val="C8960C"/>
+                </a:solidFill>
+                <a:latin typeface="Calibri"/>
+              </a:rPr>
+              <a:t>What is the project about, and why?</a:t>
+            </a:r>
+          </a:p>
+        </p:txBody>
+      </p:sp>
+      <p:sp>
+        <p:nvSpPr>
+          <p:cNvPr id="4" name="TextBox 3"/>
+          <p:cNvSpPr txBox="1"/>
+          <p:nvPr/>
+        </p:nvSpPr>
+        <p:spPr>
+          <a:xfrm>
+            <a:off x="502920" y="1737360"/>
+            <a:ext cx="11155680" cy="4206240"/>
+          </a:xfrm>
+          <a:prstGeom prst="rect">
+            <a:avLst/>
+          </a:prstGeom>
+          <a:noFill/>
+        </p:spPr>
+        <p:txBody>
+          <a:bodyPr wrap="square" anchor="t" lIns="0" rIns="0" tIns="0" bIns="0">
+            <a:spAutoFit/>
+          </a:bodyPr>
+          <a:lstStyle/>
+          <a:p>
+            <a:pPr algn="l">
+              <a:spcAft>
+                <a:spcPts val="1300"/>
+              </a:spcAft>
+            </a:pPr>
+            <a:r>
+              <a:rPr sz="1600" b="1" i="0">
+                <a:solidFill>
+                  <a:srgbClr val="C8960C"/>
+                </a:solidFill>
+                <a:latin typeface="Calibri"/>
+              </a:rPr>
+              <a:t>Volatility:  </a:t>
+            </a:r>
+            <a:r>
+              <a:rPr sz="1600" b="0" i="0">
+                <a:solidFill>
+                  <a:srgbClr val="2B2B2B"/>
+                </a:solidFill>
+                <a:latin typeface="Calibri"/>
+              </a:rPr>
+              <a:t>the size of an asset's daily price swings. It drives option pricing, value-at-risk, margins and position sizing.</a:t>
+            </a:r>
+          </a:p>
+          <a:p>
+            <a:pPr algn="l">
+              <a:spcAft>
+                <a:spcPts val="1300"/>
+              </a:spcAft>
+            </a:pPr>
+            <a:r>
+              <a:rPr sz="1600" b="1" i="0">
+                <a:solidFill>
+                  <a:srgbClr val="C8960C"/>
+                </a:solidFill>
+                <a:latin typeface="Calibri"/>
+              </a:rPr>
+              <a:t>A key asymmetry:  </a:t>
+            </a:r>
+            <a:r>
+              <a:rPr sz="1600" b="0" i="0">
+                <a:solidFill>
+                  <a:srgbClr val="2B2B2B"/>
+                </a:solidFill>
+                <a:latin typeface="Calibri"/>
+              </a:rPr>
+              <a:t>the direction of tomorrow's return is unpredictable, but its size is strongly persistent, so it can be forecast.</a:t>
+            </a:r>
+          </a:p>
+          <a:p>
+            <a:pPr algn="l">
+              <a:spcAft>
+                <a:spcPts val="1300"/>
+              </a:spcAft>
+            </a:pPr>
+            <a:r>
+              <a:rPr sz="1600" b="1" i="0">
+                <a:solidFill>
+                  <a:srgbClr val="C8960C"/>
+                </a:solidFill>
+                <a:latin typeface="Calibri"/>
+              </a:rPr>
+              <a:t>Classical models:  </a:t>
+            </a:r>
+            <a:r>
+              <a:rPr sz="1600" b="0" i="0">
+                <a:solidFill>
+                  <a:srgbClr val="2B2B2B"/>
+                </a:solidFill>
+                <a:latin typeface="Calibri"/>
+              </a:rPr>
+              <a:t>GARCH-type models have exploited this persistence for four decades.</a:t>
+            </a:r>
+          </a:p>
+          <a:p>
+            <a:pPr algn="l">
+              <a:spcAft>
+                <a:spcPts val="1300"/>
+              </a:spcAft>
+            </a:pPr>
+            <a:r>
+              <a:rPr sz="1600" b="1" i="0">
+                <a:solidFill>
+                  <a:srgbClr val="C8960C"/>
+                </a:solidFill>
+                <a:latin typeface="Calibri"/>
+              </a:rPr>
+              <a:t>The question:  </a:t>
+            </a:r>
+            <a:r>
+              <a:rPr sz="1600" b="0" i="0">
+                <a:solidFill>
+                  <a:srgbClr val="2B2B2B"/>
+                </a:solidFill>
+                <a:latin typeface="Calibri"/>
+              </a:rPr>
+              <a:t>can machine learning (XGBoost) and deep learning (LSTM) forecast next-day volatility better than these classical baselines?</a:t>
+            </a:r>
+          </a:p>
+          <a:p>
+            <a:pPr algn="l">
+              <a:spcAft>
+                <a:spcPts val="1300"/>
+              </a:spcAft>
+            </a:pPr>
+            <a:r>
+              <a:rPr sz="1600" b="1" i="0">
+                <a:solidFill>
+                  <a:srgbClr val="C8960C"/>
+                </a:solidFill>
+                <a:latin typeface="Calibri"/>
+              </a:rPr>
+              <a:t>The approach:  </a:t>
+            </a:r>
+            <a:r>
+              <a:rPr sz="1600" b="0" i="0">
+                <a:solidFill>
+                  <a:srgbClr val="2B2B2B"/>
+                </a:solidFill>
+                <a:latin typeface="Calibri"/>
+              </a:rPr>
+              <a:t>test every model fairly, in one harness, with no look-ahead bias, and check whether any difference is statistically real.</a:t>
             </a:r>
           </a:p>
         </p:txBody>
@@ -5127,7 +5995,1012 @@
           </a:bodyPr>
           <a:lstStyle/>
           <a:p>
-            <a:pPr algn="l"/>
+            <a:r>
+              <a:rPr sz="3000" b="1" i="0">
+                <a:solidFill>
+                  <a:srgbClr val="003366"/>
+                </a:solidFill>
+                <a:latin typeface="Calibri"/>
+              </a:rPr>
+              <a:t>Why Volatility Can Be Forecast</a:t>
+            </a:r>
+          </a:p>
+        </p:txBody>
+      </p:sp>
+      <p:sp>
+        <p:nvSpPr>
+          <p:cNvPr id="3" name="TextBox 2"/>
+          <p:cNvSpPr txBox="1"/>
+          <p:nvPr/>
+        </p:nvSpPr>
+        <p:spPr>
+          <a:xfrm>
+            <a:off x="502920" y="1078992"/>
+            <a:ext cx="11155680" cy="457200"/>
+          </a:xfrm>
+          <a:prstGeom prst="rect">
+            <a:avLst/>
+          </a:prstGeom>
+          <a:noFill/>
+        </p:spPr>
+        <p:txBody>
+          <a:bodyPr wrap="square" anchor="t" lIns="0" rIns="0" tIns="0" bIns="0">
+            <a:spAutoFit/>
+          </a:bodyPr>
+          <a:lstStyle/>
+          <a:p>
+            <a:r>
+              <a:rPr sz="1500" b="1" i="0">
+                <a:solidFill>
+                  <a:srgbClr val="C8960C"/>
+                </a:solidFill>
+                <a:latin typeface="Calibri"/>
+              </a:rPr>
+              <a:t>Direction is noise; size is persistent</a:t>
+            </a:r>
+          </a:p>
+        </p:txBody>
+      </p:sp>
+      <p:sp>
+        <p:nvSpPr>
+          <p:cNvPr id="4" name="TextBox 3"/>
+          <p:cNvSpPr txBox="1"/>
+          <p:nvPr/>
+        </p:nvSpPr>
+        <p:spPr>
+          <a:xfrm>
+            <a:off x="502920" y="1783080"/>
+            <a:ext cx="5486400" cy="4023360"/>
+          </a:xfrm>
+          <a:prstGeom prst="rect">
+            <a:avLst/>
+          </a:prstGeom>
+          <a:noFill/>
+        </p:spPr>
+        <p:txBody>
+          <a:bodyPr wrap="square" anchor="t" lIns="0" rIns="0" tIns="0" bIns="0">
+            <a:spAutoFit/>
+          </a:bodyPr>
+          <a:lstStyle/>
+          <a:p>
+            <a:pPr algn="l">
+              <a:spcAft>
+                <a:spcPts val="1200"/>
+              </a:spcAft>
+            </a:pPr>
+            <a:r>
+              <a:rPr sz="1600" b="1" i="0">
+                <a:solidFill>
+                  <a:srgbClr val="C8960C"/>
+                </a:solidFill>
+                <a:latin typeface="Calibri"/>
+              </a:rPr>
+              <a:t>Returns:  </a:t>
+            </a:r>
+            <a:r>
+              <a:rPr sz="1600" b="0" i="0">
+                <a:solidFill>
+                  <a:srgbClr val="2B2B2B"/>
+                </a:solidFill>
+                <a:latin typeface="Calibri"/>
+              </a:rPr>
+              <a:t>show no autocorrelation. Past returns do not predict the direction of the next one.</a:t>
+            </a:r>
+          </a:p>
+          <a:p>
+            <a:pPr algn="l">
+              <a:spcAft>
+                <a:spcPts val="1200"/>
+              </a:spcAft>
+            </a:pPr>
+            <a:r>
+              <a:rPr sz="1600" b="1" i="0">
+                <a:solidFill>
+                  <a:srgbClr val="C8960C"/>
+                </a:solidFill>
+                <a:latin typeface="Calibri"/>
+              </a:rPr>
+              <a:t>Absolute returns:  </a:t>
+            </a:r>
+            <a:r>
+              <a:rPr sz="1600" b="0" i="0">
+                <a:solidFill>
+                  <a:srgbClr val="2B2B2B"/>
+                </a:solidFill>
+                <a:latin typeface="Calibri"/>
+              </a:rPr>
+              <a:t>show strong, slowly decaying autocorrelation. Big days cluster together.</a:t>
+            </a:r>
+          </a:p>
+          <a:p>
+            <a:pPr algn="l">
+              <a:spcAft>
+                <a:spcPts val="1200"/>
+              </a:spcAft>
+            </a:pPr>
+            <a:r>
+              <a:rPr sz="1600" b="1" i="0">
+                <a:solidFill>
+                  <a:srgbClr val="C8960C"/>
+                </a:solidFill>
+                <a:latin typeface="Calibri"/>
+              </a:rPr>
+              <a:t>Volatility clustering:  </a:t>
+            </a:r>
+            <a:r>
+              <a:rPr sz="1600" b="0" i="0">
+                <a:solidFill>
+                  <a:srgbClr val="2B2B2B"/>
+                </a:solidFill>
+                <a:latin typeface="Calibri"/>
+              </a:rPr>
+              <a:t>this persistence is the one signal every model in this study exploits.</a:t>
+            </a:r>
+          </a:p>
+        </p:txBody>
+      </p:sp>
+      <p:pic>
+        <p:nvPicPr>
+          <p:cNvPr id="5" name="Picture 4" descr="fig_correlogram.png"/>
+          <p:cNvPicPr>
+            <a:picLocks noChangeAspect="1"/>
+          </p:cNvPicPr>
+          <p:nvPr/>
+        </p:nvPicPr>
+        <p:blipFill>
+          <a:blip r:embed="rId2"/>
+          <a:stretch>
+            <a:fillRect/>
+          </a:stretch>
+        </p:blipFill>
+        <p:spPr>
+          <a:xfrm>
+            <a:off x="6263640" y="2955688"/>
+            <a:ext cx="5394960" cy="1769583"/>
+          </a:xfrm>
+          <a:prstGeom prst="rect">
+            <a:avLst/>
+          </a:prstGeom>
+        </p:spPr>
+      </p:pic>
+    </p:spTree>
+  </p:cSld>
+  <p:clrMapOvr>
+    <a:masterClrMapping/>
+  </p:clrMapOvr>
+</p:sld>
+</file>
+
+<file path=ppt/slides/slide4.xml><?xml version="1.0" encoding="utf-8"?>
+<p:sld xmlns:a="http://schemas.openxmlformats.org/drawingml/2006/main" xmlns:p="http://schemas.openxmlformats.org/presentationml/2006/main" xmlns:r="http://schemas.openxmlformats.org/officeDocument/2006/relationships">
+  <p:cSld>
+    <p:spTree>
+      <p:nvGrpSpPr>
+        <p:cNvPr id="1" name=""/>
+        <p:cNvGrpSpPr/>
+        <p:nvPr/>
+      </p:nvGrpSpPr>
+      <p:grpSpPr/>
+      <p:sp>
+        <p:nvSpPr>
+          <p:cNvPr id="2" name="TextBox 1"/>
+          <p:cNvSpPr txBox="1"/>
+          <p:nvPr/>
+        </p:nvSpPr>
+        <p:spPr>
+          <a:xfrm>
+            <a:off x="502920" y="384048"/>
+            <a:ext cx="11155680" cy="914400"/>
+          </a:xfrm>
+          <a:prstGeom prst="rect">
+            <a:avLst/>
+          </a:prstGeom>
+          <a:noFill/>
+        </p:spPr>
+        <p:txBody>
+          <a:bodyPr wrap="square" anchor="t" lIns="0" rIns="0" tIns="0" bIns="0">
+            <a:spAutoFit/>
+          </a:bodyPr>
+          <a:lstStyle/>
+          <a:p>
+            <a:r>
+              <a:rPr sz="3000" b="1" i="0">
+                <a:solidFill>
+                  <a:srgbClr val="003366"/>
+                </a:solidFill>
+                <a:latin typeface="Calibri"/>
+              </a:rPr>
+              <a:t>Objectives</a:t>
+            </a:r>
+          </a:p>
+        </p:txBody>
+      </p:sp>
+      <p:sp>
+        <p:nvSpPr>
+          <p:cNvPr id="3" name="TextBox 2"/>
+          <p:cNvSpPr txBox="1"/>
+          <p:nvPr/>
+        </p:nvSpPr>
+        <p:spPr>
+          <a:xfrm>
+            <a:off x="502920" y="1737360"/>
+            <a:ext cx="11155680" cy="4206240"/>
+          </a:xfrm>
+          <a:prstGeom prst="rect">
+            <a:avLst/>
+          </a:prstGeom>
+          <a:noFill/>
+        </p:spPr>
+        <p:txBody>
+          <a:bodyPr wrap="square" anchor="t" lIns="0" rIns="0" tIns="0" bIns="0">
+            <a:spAutoFit/>
+          </a:bodyPr>
+          <a:lstStyle/>
+          <a:p>
+            <a:pPr algn="l">
+              <a:spcAft>
+                <a:spcPts val="1200"/>
+              </a:spcAft>
+            </a:pPr>
+            <a:r>
+              <a:rPr sz="1600" b="1" i="0">
+                <a:solidFill>
+                  <a:srgbClr val="C8960C"/>
+                </a:solidFill>
+                <a:latin typeface="Calibri"/>
+              </a:rPr>
+              <a:t>1.  </a:t>
+            </a:r>
+            <a:r>
+              <a:rPr sz="1600" b="0" i="0">
+                <a:solidFill>
+                  <a:srgbClr val="2B2B2B"/>
+                </a:solidFill>
+                <a:latin typeface="Calibri"/>
+              </a:rPr>
+              <a:t>Build honest classical baselines: naive, rolling, EWMA, and the GARCH family (GARCH, GJR-GARCH, EGARCH).</a:t>
+            </a:r>
+          </a:p>
+          <a:p>
+            <a:pPr algn="l">
+              <a:spcAft>
+                <a:spcPts val="1200"/>
+              </a:spcAft>
+            </a:pPr>
+            <a:r>
+              <a:rPr sz="1600" b="1" i="0">
+                <a:solidFill>
+                  <a:srgbClr val="C8960C"/>
+                </a:solidFill>
+                <a:latin typeface="Calibri"/>
+              </a:rPr>
+              <a:t>2.  </a:t>
+            </a:r>
+            <a:r>
+              <a:rPr sz="1600" b="0" i="0">
+                <a:solidFill>
+                  <a:srgbClr val="2B2B2B"/>
+                </a:solidFill>
+                <a:latin typeface="Calibri"/>
+              </a:rPr>
+              <a:t>Build a leak-free walk-forward evaluation with RMSE, MAE, QLIKE and the Diebold–Mariano test.</a:t>
+            </a:r>
+          </a:p>
+          <a:p>
+            <a:pPr algn="l">
+              <a:spcAft>
+                <a:spcPts val="1200"/>
+              </a:spcAft>
+            </a:pPr>
+            <a:r>
+              <a:rPr sz="1600" b="1" i="0">
+                <a:solidFill>
+                  <a:srgbClr val="C8960C"/>
+                </a:solidFill>
+                <a:latin typeface="Calibri"/>
+              </a:rPr>
+              <a:t>3.  </a:t>
+            </a:r>
+            <a:r>
+              <a:rPr sz="1600" b="0" i="0">
+                <a:solidFill>
+                  <a:srgbClr val="2B2B2B"/>
+                </a:solidFill>
+                <a:latin typeface="Calibri"/>
+              </a:rPr>
+              <a:t>Build a walk-forward XGBoost forecaster with justified features.</a:t>
+            </a:r>
+          </a:p>
+          <a:p>
+            <a:pPr algn="l">
+              <a:spcAft>
+                <a:spcPts val="1200"/>
+              </a:spcAft>
+            </a:pPr>
+            <a:r>
+              <a:rPr sz="1600" b="1" i="0">
+                <a:solidFill>
+                  <a:srgbClr val="C8960C"/>
+                </a:solidFill>
+                <a:latin typeface="Calibri"/>
+              </a:rPr>
+              <a:t>4.  </a:t>
+            </a:r>
+            <a:r>
+              <a:rPr sz="1600" b="0" i="0">
+                <a:solidFill>
+                  <a:srgbClr val="2B2B2B"/>
+                </a:solidFill>
+                <a:latin typeface="Calibri"/>
+              </a:rPr>
+              <a:t>Build and regularize an LSTM forecaster with explicit anti-leakage guards.</a:t>
+            </a:r>
+          </a:p>
+          <a:p>
+            <a:pPr algn="l">
+              <a:spcAft>
+                <a:spcPts val="1200"/>
+              </a:spcAft>
+            </a:pPr>
+            <a:r>
+              <a:rPr sz="1600" b="1" i="0">
+                <a:solidFill>
+                  <a:srgbClr val="C8960C"/>
+                </a:solidFill>
+                <a:latin typeface="Calibri"/>
+              </a:rPr>
+              <a:t>5.  </a:t>
+            </a:r>
+            <a:r>
+              <a:rPr sz="1600" b="0" i="0">
+                <a:solidFill>
+                  <a:srgbClr val="2B2B2B"/>
+                </a:solidFill>
+                <a:latin typeface="Calibri"/>
+              </a:rPr>
+              <a:t>Compare all models on one shared test window and test whether the differences are significant.</a:t>
+            </a:r>
+          </a:p>
+          <a:p>
+            <a:pPr algn="l">
+              <a:spcAft>
+                <a:spcPts val="1200"/>
+              </a:spcAft>
+            </a:pPr>
+            <a:r>
+              <a:rPr sz="1600" b="1" i="0">
+                <a:solidFill>
+                  <a:srgbClr val="C8960C"/>
+                </a:solidFill>
+                <a:latin typeface="Calibri"/>
+              </a:rPr>
+              <a:t>6.  </a:t>
+            </a:r>
+            <a:r>
+              <a:rPr sz="1600" b="0" i="0">
+                <a:solidFill>
+                  <a:srgbClr val="2B2B2B"/>
+                </a:solidFill>
+                <a:latin typeface="Calibri"/>
+              </a:rPr>
+              <a:t>Deliver a reproducible, modular codebase.</a:t>
+            </a:r>
+          </a:p>
+        </p:txBody>
+      </p:sp>
+    </p:spTree>
+  </p:cSld>
+  <p:clrMapOvr>
+    <a:masterClrMapping/>
+  </p:clrMapOvr>
+</p:sld>
+</file>
+
+<file path=ppt/slides/slide5.xml><?xml version="1.0" encoding="utf-8"?>
+<p:sld xmlns:a="http://schemas.openxmlformats.org/drawingml/2006/main" xmlns:p="http://schemas.openxmlformats.org/presentationml/2006/main" xmlns:r="http://schemas.openxmlformats.org/officeDocument/2006/relationships">
+  <p:cSld>
+    <p:spTree>
+      <p:nvGrpSpPr>
+        <p:cNvPr id="1" name=""/>
+        <p:cNvGrpSpPr/>
+        <p:nvPr/>
+      </p:nvGrpSpPr>
+      <p:grpSpPr/>
+      <p:sp>
+        <p:nvSpPr>
+          <p:cNvPr id="2" name="TextBox 1"/>
+          <p:cNvSpPr txBox="1"/>
+          <p:nvPr/>
+        </p:nvSpPr>
+        <p:spPr>
+          <a:xfrm>
+            <a:off x="502920" y="384048"/>
+            <a:ext cx="11155680" cy="914400"/>
+          </a:xfrm>
+          <a:prstGeom prst="rect">
+            <a:avLst/>
+          </a:prstGeom>
+          <a:noFill/>
+        </p:spPr>
+        <p:txBody>
+          <a:bodyPr wrap="square" anchor="t" lIns="0" rIns="0" tIns="0" bIns="0">
+            <a:spAutoFit/>
+          </a:bodyPr>
+          <a:lstStyle/>
+          <a:p>
+            <a:r>
+              <a:rPr sz="3000" b="1" i="0">
+                <a:solidFill>
+                  <a:srgbClr val="003366"/>
+                </a:solidFill>
+                <a:latin typeface="Calibri"/>
+              </a:rPr>
+              <a:t>Dataset: S&amp;P 500 Daily Returns</a:t>
+            </a:r>
+          </a:p>
+        </p:txBody>
+      </p:sp>
+      <p:sp>
+        <p:nvSpPr>
+          <p:cNvPr id="3" name="TextBox 2"/>
+          <p:cNvSpPr txBox="1"/>
+          <p:nvPr/>
+        </p:nvSpPr>
+        <p:spPr>
+          <a:xfrm>
+            <a:off x="502920" y="1078992"/>
+            <a:ext cx="11155680" cy="457200"/>
+          </a:xfrm>
+          <a:prstGeom prst="rect">
+            <a:avLst/>
+          </a:prstGeom>
+          <a:noFill/>
+        </p:spPr>
+        <p:txBody>
+          <a:bodyPr wrap="square" anchor="t" lIns="0" rIns="0" tIns="0" bIns="0">
+            <a:spAutoFit/>
+          </a:bodyPr>
+          <a:lstStyle/>
+          <a:p>
+            <a:r>
+              <a:rPr sz="1500" b="1" i="0">
+                <a:solidFill>
+                  <a:srgbClr val="C8960C"/>
+                </a:solidFill>
+                <a:latin typeface="Calibri"/>
+              </a:rPr>
+              <a:t>Source: Yahoo Finance (^GSPC), auto-adjusted close</a:t>
+            </a:r>
+          </a:p>
+        </p:txBody>
+      </p:sp>
+      <p:sp>
+        <p:nvSpPr>
+          <p:cNvPr id="4" name="Rounded Rectangle 3"/>
+          <p:cNvSpPr/>
+          <p:nvPr/>
+        </p:nvSpPr>
+        <p:spPr>
+          <a:xfrm>
+            <a:off x="502920" y="1828800"/>
+            <a:ext cx="2578608" cy="1554480"/>
+          </a:xfrm>
+          <a:prstGeom prst="roundRect">
+            <a:avLst/>
+          </a:prstGeom>
+          <a:solidFill>
+            <a:srgbClr val="F7EFDD"/>
+          </a:solidFill>
+          <a:ln>
+            <a:noFill/>
+          </a:ln>
+          <a:effectLst/>
+        </p:spPr>
+        <p:style>
+          <a:lnRef idx="1">
+            <a:schemeClr val="accent1"/>
+          </a:lnRef>
+          <a:fillRef idx="3">
+            <a:schemeClr val="accent1"/>
+          </a:fillRef>
+          <a:effectRef idx="2">
+            <a:schemeClr val="accent1"/>
+          </a:effectRef>
+          <a:fontRef idx="minor">
+            <a:schemeClr val="lt1"/>
+          </a:fontRef>
+        </p:style>
+        <p:txBody>
+          <a:bodyPr rtlCol="0" anchor="ctr"/>
+          <a:lstStyle/>
+          <a:p>
+            <a:pPr algn="ctr"/>
+          </a:p>
+        </p:txBody>
+      </p:sp>
+      <p:sp>
+        <p:nvSpPr>
+          <p:cNvPr id="5" name="TextBox 4"/>
+          <p:cNvSpPr txBox="1"/>
+          <p:nvPr/>
+        </p:nvSpPr>
+        <p:spPr>
+          <a:xfrm>
+            <a:off x="502920" y="2011680"/>
+            <a:ext cx="2578608" cy="1188720"/>
+          </a:xfrm>
+          <a:prstGeom prst="rect">
+            <a:avLst/>
+          </a:prstGeom>
+          <a:noFill/>
+        </p:spPr>
+        <p:txBody>
+          <a:bodyPr wrap="square" anchor="ctr" lIns="0" rIns="0" tIns="0" bIns="0">
+            <a:spAutoFit/>
+          </a:bodyPr>
+          <a:lstStyle/>
+          <a:p>
+            <a:pPr algn="ctr"/>
+            <a:r>
+              <a:rPr sz="3000" b="1" i="0">
+                <a:solidFill>
+                  <a:srgbClr val="003366"/>
+                </a:solidFill>
+                <a:latin typeface="Calibri"/>
+              </a:rPr>
+              <a:t>4,277</a:t>
+            </a:r>
+          </a:p>
+          <a:p>
+            <a:pPr algn="ctr"/>
+            <a:r>
+              <a:rPr sz="1300" b="0" i="0">
+                <a:solidFill>
+                  <a:srgbClr val="555555"/>
+                </a:solidFill>
+                <a:latin typeface="Calibri"/>
+              </a:rPr>
+              <a:t>trading days</a:t>
+            </a:r>
+          </a:p>
+        </p:txBody>
+      </p:sp>
+      <p:sp>
+        <p:nvSpPr>
+          <p:cNvPr id="6" name="Rounded Rectangle 5"/>
+          <p:cNvSpPr/>
+          <p:nvPr/>
+        </p:nvSpPr>
+        <p:spPr>
+          <a:xfrm>
+            <a:off x="3346704" y="1828800"/>
+            <a:ext cx="2578608" cy="1554480"/>
+          </a:xfrm>
+          <a:prstGeom prst="roundRect">
+            <a:avLst/>
+          </a:prstGeom>
+          <a:solidFill>
+            <a:srgbClr val="F7EFDD"/>
+          </a:solidFill>
+          <a:ln>
+            <a:noFill/>
+          </a:ln>
+          <a:effectLst/>
+        </p:spPr>
+        <p:style>
+          <a:lnRef idx="1">
+            <a:schemeClr val="accent1"/>
+          </a:lnRef>
+          <a:fillRef idx="3">
+            <a:schemeClr val="accent1"/>
+          </a:fillRef>
+          <a:effectRef idx="2">
+            <a:schemeClr val="accent1"/>
+          </a:effectRef>
+          <a:fontRef idx="minor">
+            <a:schemeClr val="lt1"/>
+          </a:fontRef>
+        </p:style>
+        <p:txBody>
+          <a:bodyPr rtlCol="0" anchor="ctr"/>
+          <a:lstStyle/>
+          <a:p>
+            <a:pPr algn="ctr"/>
+          </a:p>
+        </p:txBody>
+      </p:sp>
+      <p:sp>
+        <p:nvSpPr>
+          <p:cNvPr id="7" name="TextBox 6"/>
+          <p:cNvSpPr txBox="1"/>
+          <p:nvPr/>
+        </p:nvSpPr>
+        <p:spPr>
+          <a:xfrm>
+            <a:off x="3346704" y="2011680"/>
+            <a:ext cx="2578608" cy="1188720"/>
+          </a:xfrm>
+          <a:prstGeom prst="rect">
+            <a:avLst/>
+          </a:prstGeom>
+          <a:noFill/>
+        </p:spPr>
+        <p:txBody>
+          <a:bodyPr wrap="square" anchor="ctr" lIns="0" rIns="0" tIns="0" bIns="0">
+            <a:spAutoFit/>
+          </a:bodyPr>
+          <a:lstStyle/>
+          <a:p>
+            <a:pPr algn="ctr"/>
+            <a:r>
+              <a:rPr sz="3000" b="1" i="0">
+                <a:solidFill>
+                  <a:srgbClr val="003366"/>
+                </a:solidFill>
+                <a:latin typeface="Calibri"/>
+              </a:rPr>
+              <a:t>2008–2024</a:t>
+            </a:r>
+          </a:p>
+          <a:p>
+            <a:pPr algn="ctr"/>
+            <a:r>
+              <a:rPr sz="1300" b="0" i="0">
+                <a:solidFill>
+                  <a:srgbClr val="555555"/>
+                </a:solidFill>
+                <a:latin typeface="Calibri"/>
+              </a:rPr>
+              <a:t>17 years</a:t>
+            </a:r>
+          </a:p>
+        </p:txBody>
+      </p:sp>
+      <p:sp>
+        <p:nvSpPr>
+          <p:cNvPr id="8" name="Rounded Rectangle 7"/>
+          <p:cNvSpPr/>
+          <p:nvPr/>
+        </p:nvSpPr>
+        <p:spPr>
+          <a:xfrm>
+            <a:off x="6190488" y="1828800"/>
+            <a:ext cx="2578608" cy="1554480"/>
+          </a:xfrm>
+          <a:prstGeom prst="roundRect">
+            <a:avLst/>
+          </a:prstGeom>
+          <a:solidFill>
+            <a:srgbClr val="F7EFDD"/>
+          </a:solidFill>
+          <a:ln>
+            <a:noFill/>
+          </a:ln>
+          <a:effectLst/>
+        </p:spPr>
+        <p:style>
+          <a:lnRef idx="1">
+            <a:schemeClr val="accent1"/>
+          </a:lnRef>
+          <a:fillRef idx="3">
+            <a:schemeClr val="accent1"/>
+          </a:fillRef>
+          <a:effectRef idx="2">
+            <a:schemeClr val="accent1"/>
+          </a:effectRef>
+          <a:fontRef idx="minor">
+            <a:schemeClr val="lt1"/>
+          </a:fontRef>
+        </p:style>
+        <p:txBody>
+          <a:bodyPr rtlCol="0" anchor="ctr"/>
+          <a:lstStyle/>
+          <a:p>
+            <a:pPr algn="ctr"/>
+          </a:p>
+        </p:txBody>
+      </p:sp>
+      <p:sp>
+        <p:nvSpPr>
+          <p:cNvPr id="9" name="TextBox 8"/>
+          <p:cNvSpPr txBox="1"/>
+          <p:nvPr/>
+        </p:nvSpPr>
+        <p:spPr>
+          <a:xfrm>
+            <a:off x="6190488" y="2011680"/>
+            <a:ext cx="2578608" cy="1188720"/>
+          </a:xfrm>
+          <a:prstGeom prst="rect">
+            <a:avLst/>
+          </a:prstGeom>
+          <a:noFill/>
+        </p:spPr>
+        <p:txBody>
+          <a:bodyPr wrap="square" anchor="ctr" lIns="0" rIns="0" tIns="0" bIns="0">
+            <a:spAutoFit/>
+          </a:bodyPr>
+          <a:lstStyle/>
+          <a:p>
+            <a:pPr algn="ctr"/>
+            <a:r>
+              <a:rPr sz="3000" b="1" i="0">
+                <a:solidFill>
+                  <a:srgbClr val="003366"/>
+                </a:solidFill>
+                <a:latin typeface="Calibri"/>
+              </a:rPr>
+              <a:t>70 / 30</a:t>
+            </a:r>
+          </a:p>
+          <a:p>
+            <a:pPr algn="ctr"/>
+            <a:r>
+              <a:rPr sz="1300" b="0" i="0">
+                <a:solidFill>
+                  <a:srgbClr val="555555"/>
+                </a:solidFill>
+                <a:latin typeface="Calibri"/>
+              </a:rPr>
+              <a:t>train / test split</a:t>
+            </a:r>
+          </a:p>
+        </p:txBody>
+      </p:sp>
+      <p:sp>
+        <p:nvSpPr>
+          <p:cNvPr id="10" name="Rounded Rectangle 9"/>
+          <p:cNvSpPr/>
+          <p:nvPr/>
+        </p:nvSpPr>
+        <p:spPr>
+          <a:xfrm>
+            <a:off x="9034272" y="1828800"/>
+            <a:ext cx="2578608" cy="1554480"/>
+          </a:xfrm>
+          <a:prstGeom prst="roundRect">
+            <a:avLst/>
+          </a:prstGeom>
+          <a:solidFill>
+            <a:srgbClr val="F7EFDD"/>
+          </a:solidFill>
+          <a:ln>
+            <a:noFill/>
+          </a:ln>
+          <a:effectLst/>
+        </p:spPr>
+        <p:style>
+          <a:lnRef idx="1">
+            <a:schemeClr val="accent1"/>
+          </a:lnRef>
+          <a:fillRef idx="3">
+            <a:schemeClr val="accent1"/>
+          </a:fillRef>
+          <a:effectRef idx="2">
+            <a:schemeClr val="accent1"/>
+          </a:effectRef>
+          <a:fontRef idx="minor">
+            <a:schemeClr val="lt1"/>
+          </a:fontRef>
+        </p:style>
+        <p:txBody>
+          <a:bodyPr rtlCol="0" anchor="ctr"/>
+          <a:lstStyle/>
+          <a:p>
+            <a:pPr algn="ctr"/>
+          </a:p>
+        </p:txBody>
+      </p:sp>
+      <p:sp>
+        <p:nvSpPr>
+          <p:cNvPr id="11" name="TextBox 10"/>
+          <p:cNvSpPr txBox="1"/>
+          <p:nvPr/>
+        </p:nvSpPr>
+        <p:spPr>
+          <a:xfrm>
+            <a:off x="9034272" y="2011680"/>
+            <a:ext cx="2578608" cy="1188720"/>
+          </a:xfrm>
+          <a:prstGeom prst="rect">
+            <a:avLst/>
+          </a:prstGeom>
+          <a:noFill/>
+        </p:spPr>
+        <p:txBody>
+          <a:bodyPr wrap="square" anchor="ctr" lIns="0" rIns="0" tIns="0" bIns="0">
+            <a:spAutoFit/>
+          </a:bodyPr>
+          <a:lstStyle/>
+          <a:p>
+            <a:pPr algn="ctr"/>
+            <a:r>
+              <a:rPr sz="3000" b="1" i="0">
+                <a:solidFill>
+                  <a:srgbClr val="003366"/>
+                </a:solidFill>
+                <a:latin typeface="Calibri"/>
+              </a:rPr>
+              <a:t>1,284</a:t>
+            </a:r>
+          </a:p>
+          <a:p>
+            <a:pPr algn="ctr"/>
+            <a:r>
+              <a:rPr sz="1300" b="0" i="0">
+                <a:solidFill>
+                  <a:srgbClr val="555555"/>
+                </a:solidFill>
+                <a:latin typeface="Calibri"/>
+              </a:rPr>
+              <a:t>out-of-sample days</a:t>
+            </a:r>
+          </a:p>
+        </p:txBody>
+      </p:sp>
+      <p:sp>
+        <p:nvSpPr>
+          <p:cNvPr id="12" name="TextBox 11"/>
+          <p:cNvSpPr txBox="1"/>
+          <p:nvPr/>
+        </p:nvSpPr>
+        <p:spPr>
+          <a:xfrm>
+            <a:off x="502920" y="3794760"/>
+            <a:ext cx="11155680" cy="2103120"/>
+          </a:xfrm>
+          <a:prstGeom prst="rect">
+            <a:avLst/>
+          </a:prstGeom>
+          <a:noFill/>
+        </p:spPr>
+        <p:txBody>
+          <a:bodyPr wrap="square" anchor="t" lIns="0" rIns="0" tIns="0" bIns="0">
+            <a:spAutoFit/>
+          </a:bodyPr>
+          <a:lstStyle/>
+          <a:p>
+            <a:pPr algn="l">
+              <a:spcAft>
+                <a:spcPts val="1000"/>
+              </a:spcAft>
+            </a:pPr>
+            <a:r>
+              <a:rPr sz="1600" b="1" i="0">
+                <a:solidFill>
+                  <a:srgbClr val="C8960C"/>
+                </a:solidFill>
+                <a:latin typeface="Calibri"/>
+              </a:rPr>
+              <a:t>Returns:  </a:t>
+            </a:r>
+            <a:r>
+              <a:rPr sz="1600" b="0" i="0">
+                <a:solidFill>
+                  <a:srgbClr val="2B2B2B"/>
+                </a:solidFill>
+                <a:latin typeface="Calibri"/>
+              </a:rPr>
+              <a:t>daily log returns, the standard object for volatility models.</a:t>
+            </a:r>
+          </a:p>
+          <a:p>
+            <a:pPr algn="l">
+              <a:spcAft>
+                <a:spcPts val="1000"/>
+              </a:spcAft>
+            </a:pPr>
+            <a:r>
+              <a:rPr sz="1600" b="1" i="0">
+                <a:solidFill>
+                  <a:srgbClr val="C8960C"/>
+                </a:solidFill>
+                <a:latin typeface="Calibri"/>
+              </a:rPr>
+              <a:t>Preprocessing:  </a:t>
+            </a:r>
+            <a:r>
+              <a:rPr sz="1600" b="0" i="0">
+                <a:solidFill>
+                  <a:srgbClr val="2B2B2B"/>
+                </a:solidFill>
+                <a:latin typeface="Calibri"/>
+              </a:rPr>
+              <a:t>log-difference adjusted closes; no other cleaning needed.</a:t>
+            </a:r>
+          </a:p>
+          <a:p>
+            <a:pPr algn="l">
+              <a:spcAft>
+                <a:spcPts val="1000"/>
+              </a:spcAft>
+            </a:pPr>
+            <a:r>
+              <a:rPr sz="1600" b="1" i="0">
+                <a:solidFill>
+                  <a:srgbClr val="C8960C"/>
+                </a:solidFill>
+                <a:latin typeface="Calibri"/>
+              </a:rPr>
+              <a:t>Test window:  </a:t>
+            </a:r>
+            <a:r>
+              <a:rPr sz="1600" b="0" i="0">
+                <a:solidFill>
+                  <a:srgbClr val="2B2B2B"/>
+                </a:solidFill>
+                <a:latin typeface="Calibri"/>
+              </a:rPr>
+              <a:t>the final 30% (2019-11-21 to 2024-12-30), shared by every model.</a:t>
+            </a:r>
+          </a:p>
+          <a:p>
+            <a:pPr algn="l">
+              <a:spcAft>
+                <a:spcPts val="1000"/>
+              </a:spcAft>
+            </a:pPr>
+            <a:r>
+              <a:rPr sz="1600" b="1" i="0">
+                <a:solidFill>
+                  <a:srgbClr val="C8960C"/>
+                </a:solidFill>
+                <a:latin typeface="Calibri"/>
+              </a:rPr>
+              <a:t>Stress test:  </a:t>
+            </a:r>
+            <a:r>
+              <a:rPr sz="1600" b="0" i="0">
+                <a:solidFill>
+                  <a:srgbClr val="2B2B2B"/>
+                </a:solidFill>
+                <a:latin typeface="Calibri"/>
+              </a:rPr>
+              <a:t>the window contains the COVID-2020 crash and the 2022 bear market.</a:t>
+            </a:r>
+          </a:p>
+        </p:txBody>
+      </p:sp>
+    </p:spTree>
+  </p:cSld>
+  <p:clrMapOvr>
+    <a:masterClrMapping/>
+  </p:clrMapOvr>
+</p:sld>
+</file>
+
+<file path=ppt/slides/slide6.xml><?xml version="1.0" encoding="utf-8"?>
+<p:sld xmlns:a="http://schemas.openxmlformats.org/drawingml/2006/main" xmlns:p="http://schemas.openxmlformats.org/presentationml/2006/main" xmlns:r="http://schemas.openxmlformats.org/officeDocument/2006/relationships">
+  <p:cSld>
+    <p:spTree>
+      <p:nvGrpSpPr>
+        <p:cNvPr id="1" name=""/>
+        <p:cNvGrpSpPr/>
+        <p:nvPr/>
+      </p:nvGrpSpPr>
+      <p:grpSpPr/>
+      <p:sp>
+        <p:nvSpPr>
+          <p:cNvPr id="2" name="TextBox 1"/>
+          <p:cNvSpPr txBox="1"/>
+          <p:nvPr/>
+        </p:nvSpPr>
+        <p:spPr>
+          <a:xfrm>
+            <a:off x="502920" y="384048"/>
+            <a:ext cx="11155680" cy="914400"/>
+          </a:xfrm>
+          <a:prstGeom prst="rect">
+            <a:avLst/>
+          </a:prstGeom>
+          <a:noFill/>
+        </p:spPr>
+        <p:txBody>
+          <a:bodyPr wrap="square" anchor="t" lIns="0" rIns="0" tIns="0" bIns="0">
+            <a:spAutoFit/>
+          </a:bodyPr>
+          <a:lstStyle/>
+          <a:p>
             <a:r>
               <a:rPr sz="3000" b="1" i="0">
                 <a:solidFill>
@@ -5672,8 +7545,8 @@
         </p:nvSpPr>
         <p:spPr>
           <a:xfrm>
-            <a:off x="502920" y="5897880"/>
-            <a:ext cx="11155680" cy="457200"/>
+            <a:off x="502920" y="4937760"/>
+            <a:ext cx="11155680" cy="548640"/>
           </a:xfrm>
           <a:prstGeom prst="rect">
             <a:avLst/>
@@ -5687,13 +7560,13 @@
           <a:lstStyle/>
           <a:p>
             <a:r>
-              <a:rPr sz="1200" b="0" i="1">
+              <a:rPr sz="1300" b="0" i="1">
                 <a:solidFill>
                   <a:srgbClr val="555555"/>
                 </a:solidFill>
                 <a:latin typeface="Calibri"/>
               </a:rPr>
-              <a:t>Five heavy model fits run in parallel processes; the full pipeline reproduces end-to-end in about one minute.</a:t>
+              <a:t>The five heavy model fits run in parallel processes; the full pipeline reproduces end-to-end in about one minute.</a:t>
             </a:r>
           </a:p>
         </p:txBody>
@@ -5706,7 +7579,7 @@
 </p:sld>
 </file>
 
-<file path=ppt/slides/slide4.xml><?xml version="1.0" encoding="utf-8"?>
+<file path=ppt/slides/slide7.xml><?xml version="1.0" encoding="utf-8"?>
 <p:sld xmlns:a="http://schemas.openxmlformats.org/drawingml/2006/main" xmlns:p="http://schemas.openxmlformats.org/presentationml/2006/main" xmlns:r="http://schemas.openxmlformats.org/officeDocument/2006/relationships">
   <p:cSld>
     <p:spTree>
@@ -5738,7 +7611,6 @@
           </a:bodyPr>
           <a:lstStyle/>
           <a:p>
-            <a:pPr algn="l"/>
             <a:r>
               <a:rPr sz="3000" b="1" i="0">
                 <a:solidFill>
@@ -5746,7 +7618,7 @@
                 </a:solidFill>
                 <a:latin typeface="Calibri"/>
               </a:rPr>
-              <a:t>Dataset: S&amp;P 500 Daily Returns</a:t>
+              <a:t>The Models</a:t>
             </a:r>
           </a:p>
         </p:txBody>
@@ -5780,7 +7652,7 @@
                 </a:solidFill>
                 <a:latin typeface="Calibri"/>
               </a:rPr>
-              <a:t>Source: Yahoo Finance (^GSPC), auto-adjusted close</a:t>
+              <a:t>Eight forecasters, from three-parameter recursions to a neural network</a:t>
             </a:r>
           </a:p>
         </p:txBody>
@@ -5794,581 +7666,7 @@
         <p:spPr>
           <a:xfrm>
             <a:off x="502920" y="1828800"/>
-            <a:ext cx="2578608" cy="1554480"/>
-          </a:xfrm>
-          <a:prstGeom prst="roundRect">
-            <a:avLst/>
-          </a:prstGeom>
-          <a:solidFill>
-            <a:srgbClr val="F7EFDD"/>
-          </a:solidFill>
-          <a:ln>
-            <a:noFill/>
-          </a:ln>
-          <a:effectLst/>
-        </p:spPr>
-        <p:style>
-          <a:lnRef idx="1">
-            <a:schemeClr val="accent1"/>
-          </a:lnRef>
-          <a:fillRef idx="3">
-            <a:schemeClr val="accent1"/>
-          </a:fillRef>
-          <a:effectRef idx="2">
-            <a:schemeClr val="accent1"/>
-          </a:effectRef>
-          <a:fontRef idx="minor">
-            <a:schemeClr val="lt1"/>
-          </a:fontRef>
-        </p:style>
-        <p:txBody>
-          <a:bodyPr rtlCol="0" anchor="ctr"/>
-          <a:lstStyle/>
-          <a:p>
-            <a:pPr algn="ctr"/>
-          </a:p>
-        </p:txBody>
-      </p:sp>
-      <p:sp>
-        <p:nvSpPr>
-          <p:cNvPr id="5" name="TextBox 4"/>
-          <p:cNvSpPr txBox="1"/>
-          <p:nvPr/>
-        </p:nvSpPr>
-        <p:spPr>
-          <a:xfrm>
-            <a:off x="502920" y="2011680"/>
-            <a:ext cx="2578608" cy="1188720"/>
-          </a:xfrm>
-          <a:prstGeom prst="rect">
-            <a:avLst/>
-          </a:prstGeom>
-          <a:noFill/>
-        </p:spPr>
-        <p:txBody>
-          <a:bodyPr wrap="square" anchor="ctr" lIns="0" rIns="0" tIns="0" bIns="0">
-            <a:spAutoFit/>
-          </a:bodyPr>
-          <a:lstStyle/>
-          <a:p>
-            <a:pPr algn="ctr"/>
-            <a:r>
-              <a:rPr sz="3000" b="1" i="0">
-                <a:solidFill>
-                  <a:srgbClr val="003366"/>
-                </a:solidFill>
-                <a:latin typeface="Calibri"/>
-              </a:rPr>
-              <a:t>4,277</a:t>
-            </a:r>
-          </a:p>
-          <a:p>
-            <a:pPr algn="ctr"/>
-            <a:r>
-              <a:rPr sz="1300" b="0" i="0">
-                <a:solidFill>
-                  <a:srgbClr val="555555"/>
-                </a:solidFill>
-                <a:latin typeface="Calibri"/>
-              </a:rPr>
-              <a:t>trading days</a:t>
-            </a:r>
-          </a:p>
-        </p:txBody>
-      </p:sp>
-      <p:sp>
-        <p:nvSpPr>
-          <p:cNvPr id="6" name="Rounded Rectangle 5"/>
-          <p:cNvSpPr/>
-          <p:nvPr/>
-        </p:nvSpPr>
-        <p:spPr>
-          <a:xfrm>
-            <a:off x="3346704" y="1828800"/>
-            <a:ext cx="2578608" cy="1554480"/>
-          </a:xfrm>
-          <a:prstGeom prst="roundRect">
-            <a:avLst/>
-          </a:prstGeom>
-          <a:solidFill>
-            <a:srgbClr val="F7EFDD"/>
-          </a:solidFill>
-          <a:ln>
-            <a:noFill/>
-          </a:ln>
-          <a:effectLst/>
-        </p:spPr>
-        <p:style>
-          <a:lnRef idx="1">
-            <a:schemeClr val="accent1"/>
-          </a:lnRef>
-          <a:fillRef idx="3">
-            <a:schemeClr val="accent1"/>
-          </a:fillRef>
-          <a:effectRef idx="2">
-            <a:schemeClr val="accent1"/>
-          </a:effectRef>
-          <a:fontRef idx="minor">
-            <a:schemeClr val="lt1"/>
-          </a:fontRef>
-        </p:style>
-        <p:txBody>
-          <a:bodyPr rtlCol="0" anchor="ctr"/>
-          <a:lstStyle/>
-          <a:p>
-            <a:pPr algn="ctr"/>
-          </a:p>
-        </p:txBody>
-      </p:sp>
-      <p:sp>
-        <p:nvSpPr>
-          <p:cNvPr id="7" name="TextBox 6"/>
-          <p:cNvSpPr txBox="1"/>
-          <p:nvPr/>
-        </p:nvSpPr>
-        <p:spPr>
-          <a:xfrm>
-            <a:off x="3346704" y="2011680"/>
-            <a:ext cx="2578608" cy="1188720"/>
-          </a:xfrm>
-          <a:prstGeom prst="rect">
-            <a:avLst/>
-          </a:prstGeom>
-          <a:noFill/>
-        </p:spPr>
-        <p:txBody>
-          <a:bodyPr wrap="square" anchor="ctr" lIns="0" rIns="0" tIns="0" bIns="0">
-            <a:spAutoFit/>
-          </a:bodyPr>
-          <a:lstStyle/>
-          <a:p>
-            <a:pPr algn="ctr"/>
-            <a:r>
-              <a:rPr sz="3000" b="1" i="0">
-                <a:solidFill>
-                  <a:srgbClr val="003366"/>
-                </a:solidFill>
-                <a:latin typeface="Calibri"/>
-              </a:rPr>
-              <a:t>2008–2024</a:t>
-            </a:r>
-          </a:p>
-          <a:p>
-            <a:pPr algn="ctr"/>
-            <a:r>
-              <a:rPr sz="1300" b="0" i="0">
-                <a:solidFill>
-                  <a:srgbClr val="555555"/>
-                </a:solidFill>
-                <a:latin typeface="Calibri"/>
-              </a:rPr>
-              <a:t>17 years</a:t>
-            </a:r>
-          </a:p>
-        </p:txBody>
-      </p:sp>
-      <p:sp>
-        <p:nvSpPr>
-          <p:cNvPr id="8" name="Rounded Rectangle 7"/>
-          <p:cNvSpPr/>
-          <p:nvPr/>
-        </p:nvSpPr>
-        <p:spPr>
-          <a:xfrm>
-            <a:off x="6190488" y="1828800"/>
-            <a:ext cx="2578608" cy="1554480"/>
-          </a:xfrm>
-          <a:prstGeom prst="roundRect">
-            <a:avLst/>
-          </a:prstGeom>
-          <a:solidFill>
-            <a:srgbClr val="F7EFDD"/>
-          </a:solidFill>
-          <a:ln>
-            <a:noFill/>
-          </a:ln>
-          <a:effectLst/>
-        </p:spPr>
-        <p:style>
-          <a:lnRef idx="1">
-            <a:schemeClr val="accent1"/>
-          </a:lnRef>
-          <a:fillRef idx="3">
-            <a:schemeClr val="accent1"/>
-          </a:fillRef>
-          <a:effectRef idx="2">
-            <a:schemeClr val="accent1"/>
-          </a:effectRef>
-          <a:fontRef idx="minor">
-            <a:schemeClr val="lt1"/>
-          </a:fontRef>
-        </p:style>
-        <p:txBody>
-          <a:bodyPr rtlCol="0" anchor="ctr"/>
-          <a:lstStyle/>
-          <a:p>
-            <a:pPr algn="ctr"/>
-          </a:p>
-        </p:txBody>
-      </p:sp>
-      <p:sp>
-        <p:nvSpPr>
-          <p:cNvPr id="9" name="TextBox 8"/>
-          <p:cNvSpPr txBox="1"/>
-          <p:nvPr/>
-        </p:nvSpPr>
-        <p:spPr>
-          <a:xfrm>
-            <a:off x="6190488" y="2011680"/>
-            <a:ext cx="2578608" cy="1188720"/>
-          </a:xfrm>
-          <a:prstGeom prst="rect">
-            <a:avLst/>
-          </a:prstGeom>
-          <a:noFill/>
-        </p:spPr>
-        <p:txBody>
-          <a:bodyPr wrap="square" anchor="ctr" lIns="0" rIns="0" tIns="0" bIns="0">
-            <a:spAutoFit/>
-          </a:bodyPr>
-          <a:lstStyle/>
-          <a:p>
-            <a:pPr algn="ctr"/>
-            <a:r>
-              <a:rPr sz="3000" b="1" i="0">
-                <a:solidFill>
-                  <a:srgbClr val="003366"/>
-                </a:solidFill>
-                <a:latin typeface="Calibri"/>
-              </a:rPr>
-              <a:t>70 / 30</a:t>
-            </a:r>
-          </a:p>
-          <a:p>
-            <a:pPr algn="ctr"/>
-            <a:r>
-              <a:rPr sz="1300" b="0" i="0">
-                <a:solidFill>
-                  <a:srgbClr val="555555"/>
-                </a:solidFill>
-                <a:latin typeface="Calibri"/>
-              </a:rPr>
-              <a:t>train / test split</a:t>
-            </a:r>
-          </a:p>
-        </p:txBody>
-      </p:sp>
-      <p:sp>
-        <p:nvSpPr>
-          <p:cNvPr id="10" name="Rounded Rectangle 9"/>
-          <p:cNvSpPr/>
-          <p:nvPr/>
-        </p:nvSpPr>
-        <p:spPr>
-          <a:xfrm>
-            <a:off x="9034272" y="1828800"/>
-            <a:ext cx="2578608" cy="1554480"/>
-          </a:xfrm>
-          <a:prstGeom prst="roundRect">
-            <a:avLst/>
-          </a:prstGeom>
-          <a:solidFill>
-            <a:srgbClr val="F7EFDD"/>
-          </a:solidFill>
-          <a:ln>
-            <a:noFill/>
-          </a:ln>
-          <a:effectLst/>
-        </p:spPr>
-        <p:style>
-          <a:lnRef idx="1">
-            <a:schemeClr val="accent1"/>
-          </a:lnRef>
-          <a:fillRef idx="3">
-            <a:schemeClr val="accent1"/>
-          </a:fillRef>
-          <a:effectRef idx="2">
-            <a:schemeClr val="accent1"/>
-          </a:effectRef>
-          <a:fontRef idx="minor">
-            <a:schemeClr val="lt1"/>
-          </a:fontRef>
-        </p:style>
-        <p:txBody>
-          <a:bodyPr rtlCol="0" anchor="ctr"/>
-          <a:lstStyle/>
-          <a:p>
-            <a:pPr algn="ctr"/>
-          </a:p>
-        </p:txBody>
-      </p:sp>
-      <p:sp>
-        <p:nvSpPr>
-          <p:cNvPr id="11" name="TextBox 10"/>
-          <p:cNvSpPr txBox="1"/>
-          <p:nvPr/>
-        </p:nvSpPr>
-        <p:spPr>
-          <a:xfrm>
-            <a:off x="9034272" y="2011680"/>
-            <a:ext cx="2578608" cy="1188720"/>
-          </a:xfrm>
-          <a:prstGeom prst="rect">
-            <a:avLst/>
-          </a:prstGeom>
-          <a:noFill/>
-        </p:spPr>
-        <p:txBody>
-          <a:bodyPr wrap="square" anchor="ctr" lIns="0" rIns="0" tIns="0" bIns="0">
-            <a:spAutoFit/>
-          </a:bodyPr>
-          <a:lstStyle/>
-          <a:p>
-            <a:pPr algn="ctr"/>
-            <a:r>
-              <a:rPr sz="3000" b="1" i="0">
-                <a:solidFill>
-                  <a:srgbClr val="003366"/>
-                </a:solidFill>
-                <a:latin typeface="Calibri"/>
-              </a:rPr>
-              <a:t>1,284</a:t>
-            </a:r>
-          </a:p>
-          <a:p>
-            <a:pPr algn="ctr"/>
-            <a:r>
-              <a:rPr sz="1300" b="0" i="0">
-                <a:solidFill>
-                  <a:srgbClr val="555555"/>
-                </a:solidFill>
-                <a:latin typeface="Calibri"/>
-              </a:rPr>
-              <a:t>out-of-sample days</a:t>
-            </a:r>
-          </a:p>
-        </p:txBody>
-      </p:sp>
-      <p:sp>
-        <p:nvSpPr>
-          <p:cNvPr id="12" name="TextBox 11"/>
-          <p:cNvSpPr txBox="1"/>
-          <p:nvPr/>
-        </p:nvSpPr>
-        <p:spPr>
-          <a:xfrm>
-            <a:off x="502920" y="3749039"/>
-            <a:ext cx="11155680" cy="2103120"/>
-          </a:xfrm>
-          <a:prstGeom prst="rect">
-            <a:avLst/>
-          </a:prstGeom>
-          <a:noFill/>
-        </p:spPr>
-        <p:txBody>
-          <a:bodyPr wrap="square" anchor="t" lIns="0" rIns="0" tIns="0" bIns="0">
-            <a:spAutoFit/>
-          </a:bodyPr>
-          <a:lstStyle/>
-          <a:p>
-            <a:pPr algn="l">
-              <a:spcAft>
-                <a:spcPts val="900"/>
-              </a:spcAft>
-            </a:pPr>
-            <a:r>
-              <a:rPr sz="1500" b="1" i="0">
-                <a:solidFill>
-                  <a:srgbClr val="C8960C"/>
-                </a:solidFill>
-                <a:latin typeface="Calibri"/>
-              </a:rPr>
-              <a:t>Returns:  </a:t>
-            </a:r>
-            <a:r>
-              <a:rPr sz="1500" b="0" i="0">
-                <a:solidFill>
-                  <a:srgbClr val="2B2B2B"/>
-                </a:solidFill>
-                <a:latin typeface="Calibri"/>
-              </a:rPr>
-              <a:t>daily log returns r = ln(P_t / P_{t-1}); the standard object for volatility models.</a:t>
-            </a:r>
-          </a:p>
-          <a:p>
-            <a:pPr algn="l">
-              <a:spcAft>
-                <a:spcPts val="900"/>
-              </a:spcAft>
-            </a:pPr>
-            <a:r>
-              <a:rPr sz="1500" b="1" i="0">
-                <a:solidFill>
-                  <a:srgbClr val="C8960C"/>
-                </a:solidFill>
-                <a:latin typeface="Calibri"/>
-              </a:rPr>
-              <a:t>Preprocessing:  </a:t>
-            </a:r>
-            <a:r>
-              <a:rPr sz="1500" b="0" i="0">
-                <a:solidFill>
-                  <a:srgbClr val="2B2B2B"/>
-                </a:solidFill>
-                <a:latin typeface="Calibri"/>
-              </a:rPr>
-              <a:t>log-difference adjusted closes; drop the first NaN. No other cleaning needed.</a:t>
-            </a:r>
-          </a:p>
-          <a:p>
-            <a:pPr algn="l">
-              <a:spcAft>
-                <a:spcPts val="900"/>
-              </a:spcAft>
-            </a:pPr>
-            <a:r>
-              <a:rPr sz="1500" b="1" i="0">
-                <a:solidFill>
-                  <a:srgbClr val="C8960C"/>
-                </a:solidFill>
-                <a:latin typeface="Calibri"/>
-              </a:rPr>
-              <a:t>Split:  </a:t>
-            </a:r>
-            <a:r>
-              <a:rPr sz="1500" b="0" i="0">
-                <a:solidFill>
-                  <a:srgbClr val="2B2B2B"/>
-                </a:solidFill>
-                <a:latin typeface="Calibri"/>
-              </a:rPr>
-              <a:t>the final 30% (2019-11-21 to 2024-12-30) is a strict walk-forward test window shared by every model.</a:t>
-            </a:r>
-          </a:p>
-          <a:p>
-            <a:pPr algn="l">
-              <a:spcAft>
-                <a:spcPts val="900"/>
-              </a:spcAft>
-            </a:pPr>
-            <a:r>
-              <a:rPr sz="1500" b="1" i="0">
-                <a:solidFill>
-                  <a:srgbClr val="C8960C"/>
-                </a:solidFill>
-                <a:latin typeface="Calibri"/>
-              </a:rPr>
-              <a:t>Stress test:  </a:t>
-            </a:r>
-            <a:r>
-              <a:rPr sz="1500" b="0" i="0">
-                <a:solidFill>
-                  <a:srgbClr val="2B2B2B"/>
-                </a:solidFill>
-                <a:latin typeface="Calibri"/>
-              </a:rPr>
-              <a:t>the test window contains the COVID-2020 crash and the 2022 bear market.</a:t>
-            </a:r>
-          </a:p>
-        </p:txBody>
-      </p:sp>
-    </p:spTree>
-  </p:cSld>
-  <p:clrMapOvr>
-    <a:masterClrMapping/>
-  </p:clrMapOvr>
-</p:sld>
-</file>
-
-<file path=ppt/slides/slide5.xml><?xml version="1.0" encoding="utf-8"?>
-<p:sld xmlns:a="http://schemas.openxmlformats.org/drawingml/2006/main" xmlns:p="http://schemas.openxmlformats.org/presentationml/2006/main" xmlns:r="http://schemas.openxmlformats.org/officeDocument/2006/relationships">
-  <p:cSld>
-    <p:spTree>
-      <p:nvGrpSpPr>
-        <p:cNvPr id="1" name=""/>
-        <p:cNvGrpSpPr/>
-        <p:nvPr/>
-      </p:nvGrpSpPr>
-      <p:grpSpPr/>
-      <p:sp>
-        <p:nvSpPr>
-          <p:cNvPr id="2" name="TextBox 1"/>
-          <p:cNvSpPr txBox="1"/>
-          <p:nvPr/>
-        </p:nvSpPr>
-        <p:spPr>
-          <a:xfrm>
-            <a:off x="502920" y="384048"/>
-            <a:ext cx="11155680" cy="914400"/>
-          </a:xfrm>
-          <a:prstGeom prst="rect">
-            <a:avLst/>
-          </a:prstGeom>
-          <a:noFill/>
-        </p:spPr>
-        <p:txBody>
-          <a:bodyPr wrap="square" anchor="t" lIns="0" rIns="0" tIns="0" bIns="0">
-            <a:spAutoFit/>
-          </a:bodyPr>
-          <a:lstStyle/>
-          <a:p>
-            <a:pPr algn="l"/>
-            <a:r>
-              <a:rPr sz="3000" b="1" i="0">
-                <a:solidFill>
-                  <a:srgbClr val="003366"/>
-                </a:solidFill>
-                <a:latin typeface="Calibri"/>
-              </a:rPr>
-              <a:t>Approach &amp; Code</a:t>
-            </a:r>
-          </a:p>
-        </p:txBody>
-      </p:sp>
-      <p:sp>
-        <p:nvSpPr>
-          <p:cNvPr id="3" name="TextBox 2"/>
-          <p:cNvSpPr txBox="1"/>
-          <p:nvPr/>
-        </p:nvSpPr>
-        <p:spPr>
-          <a:xfrm>
-            <a:off x="502920" y="1078992"/>
-            <a:ext cx="11155680" cy="457200"/>
-          </a:xfrm>
-          <a:prstGeom prst="rect">
-            <a:avLst/>
-          </a:prstGeom>
-          <a:noFill/>
-        </p:spPr>
-        <p:txBody>
-          <a:bodyPr wrap="square" anchor="t" lIns="0" rIns="0" tIns="0" bIns="0">
-            <a:spAutoFit/>
-          </a:bodyPr>
-          <a:lstStyle/>
-          <a:p>
-            <a:r>
-              <a:rPr sz="1500" b="1" i="0">
-                <a:solidFill>
-                  <a:srgbClr val="C8960C"/>
-                </a:solidFill>
-                <a:latin typeface="Calibri"/>
-              </a:rPr>
-              <a:t>The modular volforecast package — no look-ahead anywhere</a:t>
-            </a:r>
-          </a:p>
-        </p:txBody>
-      </p:sp>
-      <p:sp>
-        <p:nvSpPr>
-          <p:cNvPr id="4" name="Rounded Rectangle 3"/>
-          <p:cNvSpPr/>
-          <p:nvPr/>
-        </p:nvSpPr>
-        <p:spPr>
-          <a:xfrm>
-            <a:off x="502920" y="1828800"/>
-            <a:ext cx="5349240" cy="4114800"/>
+            <a:ext cx="5349240" cy="4023360"/>
           </a:xfrm>
           <a:prstGeom prst="roundRect">
             <a:avLst/>
@@ -6412,7 +7710,7 @@
         <p:spPr>
           <a:xfrm>
             <a:off x="731520" y="2057400"/>
-            <a:ext cx="4892040" cy="3749039"/>
+            <a:ext cx="4892040" cy="3657600"/>
           </a:xfrm>
           <a:prstGeom prst="rect">
             <a:avLst/>
@@ -6437,7 +7735,7 @@
                 </a:solidFill>
                 <a:latin typeface="Calibri"/>
               </a:rPr>
-              <a:t>Pipeline (volforecast/)</a:t>
+              <a:t>Classical</a:t>
             </a:r>
           </a:p>
           <a:p>
@@ -6447,13 +7745,22 @@
               </a:spcAft>
             </a:pPr>
             <a:r>
+              <a:rPr sz="1450" b="1" i="0">
+                <a:solidFill>
+                  <a:srgbClr val="C8960C"/>
+                </a:solidFill>
+                <a:latin typeface="Calibri"/>
+              </a:rPr>
+              <a:t>Naive:  </a:t>
+            </a:r>
+            <a:r>
               <a:rPr sz="1450" b="0" i="0">
                 <a:solidFill>
                   <a:srgbClr val="2B2B2B"/>
                 </a:solidFill>
                 <a:latin typeface="Calibri"/>
               </a:rPr>
-              <a:t>config · data · metrics · features</a:t>
+              <a:t>yesterday's squared return</a:t>
             </a:r>
           </a:p>
           <a:p>
@@ -6463,13 +7770,22 @@
               </a:spcAft>
             </a:pPr>
             <a:r>
+              <a:rPr sz="1450" b="1" i="0">
+                <a:solidFill>
+                  <a:srgbClr val="C8960C"/>
+                </a:solidFill>
+                <a:latin typeface="Calibri"/>
+              </a:rPr>
+              <a:t>Rolling(21):  </a:t>
+            </a:r>
+            <a:r>
               <a:rPr sz="1450" b="0" i="0">
                 <a:solidFill>
                   <a:srgbClr val="2B2B2B"/>
                 </a:solidFill>
                 <a:latin typeface="Calibri"/>
               </a:rPr>
-              <a:t>baselines · ml_xgboost · ml_lstm</a:t>
+              <a:t>variance of last 21 days</a:t>
             </a:r>
           </a:p>
           <a:p>
@@ -6479,13 +7795,22 @@
               </a:spcAft>
             </a:pPr>
             <a:r>
+              <a:rPr sz="1450" b="1" i="0">
+                <a:solidFill>
+                  <a:srgbClr val="C8960C"/>
+                </a:solidFill>
+                <a:latin typeface="Calibri"/>
+              </a:rPr>
+              <a:t>EWMA(0.94):  </a:t>
+            </a:r>
+            <a:r>
               <a:rPr sz="1450" b="0" i="0">
                 <a:solidFill>
                   <a:srgbClr val="2B2B2B"/>
                 </a:solidFill>
                 <a:latin typeface="Calibri"/>
               </a:rPr>
-              <a:t>evaluate · pipeline (process-parallel)</a:t>
+              <a:t>RiskMetrics decay</a:t>
             </a:r>
           </a:p>
           <a:p>
@@ -6495,13 +7820,22 @@
               </a:spcAft>
             </a:pPr>
             <a:r>
+              <a:rPr sz="1450" b="1" i="0">
+                <a:solidFill>
+                  <a:srgbClr val="C8960C"/>
+                </a:solidFill>
+                <a:latin typeface="Calibri"/>
+              </a:rPr>
+              <a:t>GARCH(1,1):  </a:t>
+            </a:r>
+            <a:r>
               <a:rPr sz="1450" b="0" i="0">
                 <a:solidFill>
                   <a:srgbClr val="2B2B2B"/>
                 </a:solidFill>
                 <a:latin typeface="Calibri"/>
               </a:rPr>
-              <a:t>Walk-forward: refit periodically, roll</a:t>
+              <a:t>ω + α r² + β σ²</a:t>
             </a:r>
           </a:p>
           <a:p>
@@ -6511,13 +7845,22 @@
               </a:spcAft>
             </a:pPr>
             <a:r>
+              <a:rPr sz="1450" b="1" i="0">
+                <a:solidFill>
+                  <a:srgbClr val="C8960C"/>
+                </a:solidFill>
+                <a:latin typeface="Calibri"/>
+              </a:rPr>
+              <a:t>GJR / EGARCH:  </a:t>
+            </a:r>
+            <a:r>
               <a:rPr sz="1450" b="0" i="0">
                 <a:solidFill>
                   <a:srgbClr val="2B2B2B"/>
                 </a:solidFill>
                 <a:latin typeface="Calibri"/>
               </a:rPr>
-              <a:t>forward on observed returns only</a:t>
+              <a:t>add the leverage effect</a:t>
             </a:r>
           </a:p>
         </p:txBody>
@@ -6531,7 +7874,7 @@
         <p:spPr>
           <a:xfrm>
             <a:off x="6035040" y="1828800"/>
-            <a:ext cx="5623560" cy="4114800"/>
+            <a:ext cx="5623560" cy="4023360"/>
           </a:xfrm>
           <a:prstGeom prst="roundRect">
             <a:avLst/>
@@ -6575,7 +7918,7 @@
         <p:spPr>
           <a:xfrm>
             <a:off x="6263640" y="2057400"/>
-            <a:ext cx="5166360" cy="3749039"/>
+            <a:ext cx="5166360" cy="3657600"/>
           </a:xfrm>
           <a:prstGeom prst="rect">
             <a:avLst/>
@@ -6600,7 +7943,7 @@
                 </a:solidFill>
                 <a:latin typeface="Calibri"/>
               </a:rPr>
-              <a:t>Eight models compared</a:t>
+              <a:t>Learned</a:t>
             </a:r>
           </a:p>
           <a:p>
@@ -6616,7 +7959,7 @@
                 </a:solidFill>
                 <a:latin typeface="Calibri"/>
               </a:rPr>
-              <a:t>Baselines:  </a:t>
+              <a:t>XGBoost:  </a:t>
             </a:r>
             <a:r>
               <a:rPr sz="1450" b="0" i="0">
@@ -6625,7 +7968,7 @@
                 </a:solidFill>
                 <a:latin typeface="Calibri"/>
               </a:rPr>
-              <a:t>Naive, Rolling(21), EWMA(0.94)</a:t>
+              <a:t>gradient-boosted trees, refit monthly</a:t>
             </a:r>
           </a:p>
           <a:p>
@@ -6641,7 +7984,7 @@
                 </a:solidFill>
                 <a:latin typeface="Calibri"/>
               </a:rPr>
-              <a:t>GARCH family:  </a:t>
+              <a:t>LSTM:  </a:t>
             </a:r>
             <a:r>
               <a:rPr sz="1450" b="0" i="0">
@@ -6650,7 +7993,7 @@
                 </a:solidFill>
                 <a:latin typeface="Calibri"/>
               </a:rPr>
-              <a:t>GARCH, GJR-GARCH, EGARCH</a:t>
+              <a:t>reads 20 days of features</a:t>
             </a:r>
           </a:p>
           <a:p>
@@ -6666,7 +8009,7 @@
                 </a:solidFill>
                 <a:latin typeface="Calibri"/>
               </a:rPr>
-              <a:t>Machine learning:  </a:t>
+              <a:t>Shared features:  </a:t>
             </a:r>
             <a:r>
               <a:rPr sz="1450" b="0" i="0">
@@ -6675,7 +8018,7 @@
                 </a:solidFill>
                 <a:latin typeface="Calibri"/>
               </a:rPr>
-              <a:t>walk-forward XGBoost</a:t>
+              <a:t>recent returns, realized variance</a:t>
             </a:r>
           </a:p>
           <a:p>
@@ -6691,7 +8034,7 @@
                 </a:solidFill>
                 <a:latin typeface="Calibri"/>
               </a:rPr>
-              <a:t>Deep learning:  </a:t>
+              <a:t>Shared target:  </a:t>
             </a:r>
             <a:r>
               <a:rPr sz="1450" b="0" i="0">
@@ -6700,7 +8043,7 @@
                 </a:solidFill>
                 <a:latin typeface="Calibri"/>
               </a:rPr>
-              <a:t>LSTM (early stopping)</a:t>
+              <a:t>log smoothed forward variance</a:t>
             </a:r>
           </a:p>
           <a:p>
@@ -6716,7 +8059,7 @@
                 </a:solidFill>
                 <a:latin typeface="Calibri"/>
               </a:rPr>
-              <a:t>Scored by:  </a:t>
+              <a:t>Guarded:  </a:t>
             </a:r>
             <a:r>
               <a:rPr sz="1450" b="0" i="0">
@@ -6725,7 +8068,7 @@
                 </a:solidFill>
                 <a:latin typeface="Calibri"/>
               </a:rPr>
-              <a:t>RMSE, MAE, QLIKE + Diebold–Mariano</a:t>
+              <a:t>train-only scaling, early stopping</a:t>
             </a:r>
           </a:p>
         </p:txBody>
@@ -6738,7 +8081,7 @@
 </p:sld>
 </file>
 
-<file path=ppt/slides/slide6.xml><?xml version="1.0" encoding="utf-8"?>
+<file path=ppt/slides/slide8.xml><?xml version="1.0" encoding="utf-8"?>
 <p:sld xmlns:a="http://schemas.openxmlformats.org/drawingml/2006/main" xmlns:p="http://schemas.openxmlformats.org/presentationml/2006/main" xmlns:r="http://schemas.openxmlformats.org/officeDocument/2006/relationships">
   <p:cSld>
     <p:spTree>
@@ -6770,7 +8113,206 @@
           </a:bodyPr>
           <a:lstStyle/>
           <a:p>
-            <a:pPr algn="l"/>
+            <a:r>
+              <a:rPr sz="3000" b="1" i="0">
+                <a:solidFill>
+                  <a:srgbClr val="003366"/>
+                </a:solidFill>
+                <a:latin typeface="Calibri"/>
+              </a:rPr>
+              <a:t>Evaluation: A Leak-Free Walk-Forward</a:t>
+            </a:r>
+          </a:p>
+        </p:txBody>
+      </p:sp>
+      <p:sp>
+        <p:nvSpPr>
+          <p:cNvPr id="3" name="TextBox 2"/>
+          <p:cNvSpPr txBox="1"/>
+          <p:nvPr/>
+        </p:nvSpPr>
+        <p:spPr>
+          <a:xfrm>
+            <a:off x="502920" y="1737360"/>
+            <a:ext cx="11155680" cy="4206240"/>
+          </a:xfrm>
+          <a:prstGeom prst="rect">
+            <a:avLst/>
+          </a:prstGeom>
+          <a:noFill/>
+        </p:spPr>
+        <p:txBody>
+          <a:bodyPr wrap="square" anchor="t" lIns="0" rIns="0" tIns="0" bIns="0">
+            <a:spAutoFit/>
+          </a:bodyPr>
+          <a:lstStyle/>
+          <a:p>
+            <a:pPr algn="l">
+              <a:spcAft>
+                <a:spcPts val="1300"/>
+              </a:spcAft>
+            </a:pPr>
+            <a:r>
+              <a:rPr sz="1600" b="1" i="0">
+                <a:solidFill>
+                  <a:srgbClr val="C8960C"/>
+                </a:solidFill>
+                <a:latin typeface="Calibri"/>
+              </a:rPr>
+              <a:t>No look-ahead:  </a:t>
+            </a:r>
+            <a:r>
+              <a:rPr sz="1600" b="0" i="0">
+                <a:solidFill>
+                  <a:srgbClr val="2B2B2B"/>
+                </a:solidFill>
+                <a:latin typeface="Calibri"/>
+              </a:rPr>
+              <a:t>the forecast for a day uses only data up to the day before. All models share one test window.</a:t>
+            </a:r>
+          </a:p>
+          <a:p>
+            <a:pPr algn="l">
+              <a:spcAft>
+                <a:spcPts val="1300"/>
+              </a:spcAft>
+            </a:pPr>
+            <a:r>
+              <a:rPr sz="1600" b="1" i="0">
+                <a:solidFill>
+                  <a:srgbClr val="C8960C"/>
+                </a:solidFill>
+                <a:latin typeface="Calibri"/>
+              </a:rPr>
+              <a:t>Periodic refit:  </a:t>
+            </a:r>
+            <a:r>
+              <a:rPr sz="1600" b="0" i="0">
+                <a:solidFill>
+                  <a:srgbClr val="2B2B2B"/>
+                </a:solidFill>
+                <a:latin typeface="Calibri"/>
+              </a:rPr>
+              <a:t>classical and ML models are re-estimated about monthly, then rolled forward on observed data.</a:t>
+            </a:r>
+          </a:p>
+          <a:p>
+            <a:pPr algn="l">
+              <a:spcAft>
+                <a:spcPts val="1300"/>
+              </a:spcAft>
+            </a:pPr>
+            <a:r>
+              <a:rPr sz="1600" b="1" i="0">
+                <a:solidFill>
+                  <a:srgbClr val="C8960C"/>
+                </a:solidFill>
+                <a:latin typeface="Calibri"/>
+              </a:rPr>
+              <a:t>QLIKE (headline):  </a:t>
+            </a:r>
+            <a:r>
+              <a:rPr sz="1600" b="0" i="0">
+                <a:solidFill>
+                  <a:srgbClr val="2B2B2B"/>
+                </a:solidFill>
+                <a:latin typeface="Calibri"/>
+              </a:rPr>
+              <a:t>robust to noise in the squared-return proxy, and it punishes under-prediction of variance.</a:t>
+            </a:r>
+          </a:p>
+          <a:p>
+            <a:pPr algn="l">
+              <a:spcAft>
+                <a:spcPts val="1300"/>
+              </a:spcAft>
+            </a:pPr>
+            <a:r>
+              <a:rPr sz="1600" b="1" i="0">
+                <a:solidFill>
+                  <a:srgbClr val="C8960C"/>
+                </a:solidFill>
+                <a:latin typeface="Calibri"/>
+              </a:rPr>
+              <a:t>RMSE / MAE:  </a:t>
+            </a:r>
+            <a:r>
+              <a:rPr sz="1600" b="0" i="0">
+                <a:solidFill>
+                  <a:srgbClr val="2B2B2B"/>
+                </a:solidFill>
+                <a:latin typeface="Calibri"/>
+              </a:rPr>
+              <a:t>point accuracy on the volatility scale, for interpretability.</a:t>
+            </a:r>
+          </a:p>
+          <a:p>
+            <a:pPr algn="l">
+              <a:spcAft>
+                <a:spcPts val="1300"/>
+              </a:spcAft>
+            </a:pPr>
+            <a:r>
+              <a:rPr sz="1600" b="1" i="0">
+                <a:solidFill>
+                  <a:srgbClr val="C8960C"/>
+                </a:solidFill>
+                <a:latin typeface="Calibri"/>
+              </a:rPr>
+              <a:t>Diebold–Mariano:  </a:t>
+            </a:r>
+            <a:r>
+              <a:rPr sz="1600" b="0" i="0">
+                <a:solidFill>
+                  <a:srgbClr val="2B2B2B"/>
+                </a:solidFill>
+                <a:latin typeface="Calibri"/>
+              </a:rPr>
+              <a:t>tests whether a gap in loss between two models is statistically real, not luck.</a:t>
+            </a:r>
+          </a:p>
+        </p:txBody>
+      </p:sp>
+    </p:spTree>
+  </p:cSld>
+  <p:clrMapOvr>
+    <a:masterClrMapping/>
+  </p:clrMapOvr>
+</p:sld>
+</file>
+
+<file path=ppt/slides/slide9.xml><?xml version="1.0" encoding="utf-8"?>
+<p:sld xmlns:a="http://schemas.openxmlformats.org/drawingml/2006/main" xmlns:p="http://schemas.openxmlformats.org/presentationml/2006/main" xmlns:r="http://schemas.openxmlformats.org/officeDocument/2006/relationships">
+  <p:cSld>
+    <p:spTree>
+      <p:nvGrpSpPr>
+        <p:cNvPr id="1" name=""/>
+        <p:cNvGrpSpPr/>
+        <p:nvPr/>
+      </p:nvGrpSpPr>
+      <p:grpSpPr/>
+      <p:sp>
+        <p:nvSpPr>
+          <p:cNvPr id="2" name="TextBox 1"/>
+          <p:cNvSpPr txBox="1"/>
+          <p:nvPr/>
+        </p:nvSpPr>
+        <p:spPr>
+          <a:xfrm>
+            <a:off x="502920" y="384048"/>
+            <a:ext cx="11155680" cy="914400"/>
+          </a:xfrm>
+          <a:prstGeom prst="rect">
+            <a:avLst/>
+          </a:prstGeom>
+          <a:noFill/>
+        </p:spPr>
+        <p:txBody>
+          <a:bodyPr wrap="square" anchor="t" lIns="0" rIns="0" tIns="0" bIns="0">
+            <a:spAutoFit/>
+          </a:bodyPr>
+          <a:lstStyle/>
+          <a:p>
             <a:r>
               <a:rPr sz="3000" b="1" i="0">
                 <a:solidFill>
@@ -6812,7 +8354,7 @@
                 </a:solidFill>
                 <a:latin typeface="Calibri"/>
               </a:rPr>
-              <a:t>Out-of-sample, 1,284 test days, sorted by QLIKE (lower = better)</a:t>
+              <a:t>Out-of-sample, 1,284 days, sorted by QLIKE (lower = better)</a:t>
             </a:r>
           </a:p>
         </p:txBody>
@@ -6844,7 +8386,7 @@
               <a:tr h="426720">
                 <a:tc>
                   <a:txBody>
-                    <a:bodyPr wrap="square"/>
+                    <a:bodyPr/>
                     <a:lstStyle/>
                     <a:p>
                       <a:pPr algn="l"/>
@@ -6867,7 +8409,7 @@
                 </a:tc>
                 <a:tc>
                   <a:txBody>
-                    <a:bodyPr wrap="square"/>
+                    <a:bodyPr/>
                     <a:lstStyle/>
                     <a:p>
                       <a:pPr algn="ctr"/>
@@ -6890,7 +8432,7 @@
                 </a:tc>
                 <a:tc>
                   <a:txBody>
-                    <a:bodyPr wrap="square"/>
+                    <a:bodyPr/>
                     <a:lstStyle/>
                     <a:p>
                       <a:pPr algn="ctr"/>
@@ -6913,7 +8455,7 @@
                 </a:tc>
                 <a:tc>
                   <a:txBody>
-                    <a:bodyPr wrap="square"/>
+                    <a:bodyPr/>
                     <a:lstStyle/>
                     <a:p>
                       <a:pPr algn="ctr"/>
@@ -6938,7 +8480,7 @@
               <a:tr h="426720">
                 <a:tc>
                   <a:txBody>
-                    <a:bodyPr wrap="square"/>
+                    <a:bodyPr/>
                     <a:lstStyle/>
                     <a:p>
                       <a:pPr algn="l"/>
@@ -6961,7 +8503,7 @@
                 </a:tc>
                 <a:tc>
                   <a:txBody>
-                    <a:bodyPr wrap="square"/>
+                    <a:bodyPr/>
                     <a:lstStyle/>
                     <a:p>
                       <a:pPr algn="ctr"/>
@@ -6984,7 +8526,7 @@
                 </a:tc>
                 <a:tc>
                   <a:txBody>
-                    <a:bodyPr wrap="square"/>
+                    <a:bodyPr/>
                     <a:lstStyle/>
                     <a:p>
                       <a:pPr algn="ctr"/>
@@ -7007,7 +8549,7 @@
                 </a:tc>
                 <a:tc>
                   <a:txBody>
-                    <a:bodyPr wrap="square"/>
+                    <a:bodyPr/>
                     <a:lstStyle/>
                     <a:p>
                       <a:pPr algn="ctr"/>
@@ -7032,7 +8574,7 @@
               <a:tr h="426720">
                 <a:tc>
                   <a:txBody>
-                    <a:bodyPr wrap="square"/>
+                    <a:bodyPr/>
                     <a:lstStyle/>
                     <a:p>
                       <a:pPr algn="l"/>
@@ -7055,7 +8597,7 @@
                 </a:tc>
                 <a:tc>
                   <a:txBody>
-                    <a:bodyPr wrap="square"/>
+                    <a:bodyPr/>
                     <a:lstStyle/>
                     <a:p>
                       <a:pPr algn="ctr"/>
@@ -7078,7 +8620,7 @@
                 </a:tc>
                 <a:tc>
                   <a:txBody>
-                    <a:bodyPr wrap="square"/>
+                    <a:bodyPr/>
                     <a:lstStyle/>
                     <a:p>
                       <a:pPr algn="ctr"/>
@@ -7101,7 +8643,7 @@
                 </a:tc>
                 <a:tc>
                   <a:txBody>
-                    <a:bodyPr wrap="square"/>
+                    <a:bodyPr/>
                     <a:lstStyle/>
                     <a:p>
                       <a:pPr algn="ctr"/>
@@ -7126,7 +8668,7 @@
               <a:tr h="426720">
                 <a:tc>
                   <a:txBody>
-                    <a:bodyPr wrap="square"/>
+                    <a:bodyPr/>
                     <a:lstStyle/>
                     <a:p>
                       <a:pPr algn="l"/>
@@ -7149,7 +8691,7 @@
                 </a:tc>
                 <a:tc>
                   <a:txBody>
-                    <a:bodyPr wrap="square"/>
+                    <a:bodyPr/>
                     <a:lstStyle/>
                     <a:p>
                       <a:pPr algn="ctr"/>
@@ -7172,7 +8714,7 @@
                 </a:tc>
                 <a:tc>
                   <a:txBody>
-                    <a:bodyPr wrap="square"/>
+                    <a:bodyPr/>
                     <a:lstStyle/>
                     <a:p>
                       <a:pPr algn="ctr"/>
@@ -7195,7 +8737,7 @@
                 </a:tc>
                 <a:tc>
                   <a:txBody>
-                    <a:bodyPr wrap="square"/>
+                    <a:bodyPr/>
                     <a:lstStyle/>
                     <a:p>
                       <a:pPr algn="ctr"/>
@@ -7220,7 +8762,7 @@
               <a:tr h="426720">
                 <a:tc>
                   <a:txBody>
-                    <a:bodyPr wrap="square"/>
+                    <a:bodyPr/>
                     <a:lstStyle/>
                     <a:p>
                       <a:pPr algn="l"/>
@@ -7243,7 +8785,7 @@
                 </a:tc>
                 <a:tc>
                   <a:txBody>
-                    <a:bodyPr wrap="square"/>
+                    <a:bodyPr/>
                     <a:lstStyle/>
                     <a:p>
                       <a:pPr algn="ctr"/>
@@ -7266,7 +8808,7 @@
                 </a:tc>
                 <a:tc>
                   <a:txBody>
-                    <a:bodyPr wrap="square"/>
+                    <a:bodyPr/>
                     <a:lstStyle/>
                     <a:p>
                       <a:pPr algn="ctr"/>
@@ -7289,7 +8831,7 @@
                 </a:tc>
                 <a:tc>
                   <a:txBody>
-                    <a:bodyPr wrap="square"/>
+                    <a:bodyPr/>
                     <a:lstStyle/>
                     <a:p>
                       <a:pPr algn="ctr"/>
@@ -7314,7 +8856,7 @@
               <a:tr h="426720">
                 <a:tc>
                   <a:txBody>
-                    <a:bodyPr wrap="square"/>
+                    <a:bodyPr/>
                     <a:lstStyle/>
                     <a:p>
                       <a:pPr algn="l"/>
@@ -7337,7 +8879,7 @@
                 </a:tc>
                 <a:tc>
                   <a:txBody>
-                    <a:bodyPr wrap="square"/>
+                    <a:bodyPr/>
                     <a:lstStyle/>
                     <a:p>
                       <a:pPr algn="ctr"/>
@@ -7360,7 +8902,7 @@
                 </a:tc>
                 <a:tc>
                   <a:txBody>
-                    <a:bodyPr wrap="square"/>
+                    <a:bodyPr/>
                     <a:lstStyle/>
                     <a:p>
                       <a:pPr algn="ctr"/>
@@ -7383,7 +8925,7 @@
                 </a:tc>
                 <a:tc>
                   <a:txBody>
-                    <a:bodyPr wrap="square"/>
+                    <a:bodyPr/>
                     <a:lstStyle/>
                     <a:p>
                       <a:pPr algn="ctr"/>
@@ -7408,7 +8950,7 @@
               <a:tr h="426720">
                 <a:tc>
                   <a:txBody>
-                    <a:bodyPr wrap="square"/>
+                    <a:bodyPr/>
                     <a:lstStyle/>
                     <a:p>
                       <a:pPr algn="l"/>
@@ -7431,7 +8973,7 @@
                 </a:tc>
                 <a:tc>
                   <a:txBody>
-                    <a:bodyPr wrap="square"/>
+                    <a:bodyPr/>
                     <a:lstStyle/>
                     <a:p>
                       <a:pPr algn="ctr"/>
@@ -7454,7 +8996,7 @@
                 </a:tc>
                 <a:tc>
                   <a:txBody>
-                    <a:bodyPr wrap="square"/>
+                    <a:bodyPr/>
                     <a:lstStyle/>
                     <a:p>
                       <a:pPr algn="ctr"/>
@@ -7477,7 +9019,7 @@
                 </a:tc>
                 <a:tc>
                   <a:txBody>
-                    <a:bodyPr wrap="square"/>
+                    <a:bodyPr/>
                     <a:lstStyle/>
                     <a:p>
                       <a:pPr algn="ctr"/>
@@ -7502,7 +9044,7 @@
               <a:tr h="426720">
                 <a:tc>
                   <a:txBody>
-                    <a:bodyPr wrap="square"/>
+                    <a:bodyPr/>
                     <a:lstStyle/>
                     <a:p>
                       <a:pPr algn="l"/>
@@ -7525,7 +9067,7 @@
                 </a:tc>
                 <a:tc>
                   <a:txBody>
-                    <a:bodyPr wrap="square"/>
+                    <a:bodyPr/>
                     <a:lstStyle/>
                     <a:p>
                       <a:pPr algn="ctr"/>
@@ -7548,7 +9090,7 @@
                 </a:tc>
                 <a:tc>
                   <a:txBody>
-                    <a:bodyPr wrap="square"/>
+                    <a:bodyPr/>
                     <a:lstStyle/>
                     <a:p>
                       <a:pPr algn="ctr"/>
@@ -7571,7 +9113,7 @@
                 </a:tc>
                 <a:tc>
                   <a:txBody>
-                    <a:bodyPr wrap="square"/>
+                    <a:bodyPr/>
                     <a:lstStyle/>
                     <a:p>
                       <a:pPr algn="ctr"/>
@@ -7596,7 +9138,7 @@
               <a:tr h="426720">
                 <a:tc>
                   <a:txBody>
-                    <a:bodyPr wrap="square"/>
+                    <a:bodyPr/>
                     <a:lstStyle/>
                     <a:p>
                       <a:pPr algn="l"/>
@@ -7619,7 +9161,7 @@
                 </a:tc>
                 <a:tc>
                   <a:txBody>
-                    <a:bodyPr wrap="square"/>
+                    <a:bodyPr/>
                     <a:lstStyle/>
                     <a:p>
                       <a:pPr algn="ctr"/>
@@ -7642,7 +9184,7 @@
                 </a:tc>
                 <a:tc>
                   <a:txBody>
-                    <a:bodyPr wrap="square"/>
+                    <a:bodyPr/>
                     <a:lstStyle/>
                     <a:p>
                       <a:pPr algn="ctr"/>
@@ -7665,7 +9207,7 @@
                 </a:tc>
                 <a:tc>
                   <a:txBody>
-                    <a:bodyPr wrap="square"/>
+                    <a:bodyPr/>
                     <a:lstStyle/>
                     <a:p>
                       <a:pPr algn="ctr"/>
@@ -7723,7 +9265,7 @@
         </p:nvSpPr>
         <p:spPr>
           <a:xfrm>
-            <a:off x="6172200" y="5166360"/>
+            <a:off x="6172200" y="5120640"/>
             <a:ext cx="5486400" cy="822960"/>
           </a:xfrm>
           <a:prstGeom prst="rect">
@@ -7744,723 +9286,7 @@
                 </a:solidFill>
                 <a:latin typeface="Calibri"/>
               </a:rPr>
-              <a:t>GARCH(1,1) wins on QLIKE. XGBoost has the best RMSE/MAE but ranks 5th on QLIKE — it is accurate on average yet slow at spikes.</a:t>
-            </a:r>
-          </a:p>
-        </p:txBody>
-      </p:sp>
-    </p:spTree>
-  </p:cSld>
-  <p:clrMapOvr>
-    <a:masterClrMapping/>
-  </p:clrMapOvr>
-</p:sld>
-</file>
-
-<file path=ppt/slides/slide7.xml><?xml version="1.0" encoding="utf-8"?>
-<p:sld xmlns:a="http://schemas.openxmlformats.org/drawingml/2006/main" xmlns:p="http://schemas.openxmlformats.org/presentationml/2006/main" xmlns:r="http://schemas.openxmlformats.org/officeDocument/2006/relationships">
-  <p:cSld>
-    <p:spTree>
-      <p:nvGrpSpPr>
-        <p:cNvPr id="1" name=""/>
-        <p:cNvGrpSpPr/>
-        <p:nvPr/>
-      </p:nvGrpSpPr>
-      <p:grpSpPr/>
-      <p:sp>
-        <p:nvSpPr>
-          <p:cNvPr id="2" name="TextBox 1"/>
-          <p:cNvSpPr txBox="1"/>
-          <p:nvPr/>
-        </p:nvSpPr>
-        <p:spPr>
-          <a:xfrm>
-            <a:off x="502920" y="384048"/>
-            <a:ext cx="11155680" cy="914400"/>
-          </a:xfrm>
-          <a:prstGeom prst="rect">
-            <a:avLst/>
-          </a:prstGeom>
-          <a:noFill/>
-        </p:spPr>
-        <p:txBody>
-          <a:bodyPr wrap="square" anchor="t" lIns="0" rIns="0" tIns="0" bIns="0">
-            <a:spAutoFit/>
-          </a:bodyPr>
-          <a:lstStyle/>
-          <a:p>
-            <a:pPr algn="l"/>
-            <a:r>
-              <a:rPr sz="3000" b="1" i="0">
-                <a:solidFill>
-                  <a:srgbClr val="003366"/>
-                </a:solidFill>
-                <a:latin typeface="Calibri"/>
-              </a:rPr>
-              <a:t>Evaluation &amp; Significance</a:t>
-            </a:r>
-          </a:p>
-        </p:txBody>
-      </p:sp>
-      <p:sp>
-        <p:nvSpPr>
-          <p:cNvPr id="3" name="TextBox 2"/>
-          <p:cNvSpPr txBox="1"/>
-          <p:nvPr/>
-        </p:nvSpPr>
-        <p:spPr>
-          <a:xfrm>
-            <a:off x="502920" y="1600200"/>
-            <a:ext cx="5486400" cy="2468880"/>
-          </a:xfrm>
-          <a:prstGeom prst="rect">
-            <a:avLst/>
-          </a:prstGeom>
-          <a:noFill/>
-        </p:spPr>
-        <p:txBody>
-          <a:bodyPr wrap="square" anchor="t" lIns="0" rIns="0" tIns="0" bIns="0">
-            <a:spAutoFit/>
-          </a:bodyPr>
-          <a:lstStyle/>
-          <a:p>
-            <a:pPr algn="l">
-              <a:spcAft>
-                <a:spcPts val="1000"/>
-              </a:spcAft>
-            </a:pPr>
-            <a:r>
-              <a:rPr sz="1500" b="1" i="0">
-                <a:solidFill>
-                  <a:srgbClr val="C8960C"/>
-                </a:solidFill>
-                <a:latin typeface="Calibri"/>
-              </a:rPr>
-              <a:t>QLIKE (headline):  </a:t>
-            </a:r>
-            <a:r>
-              <a:rPr sz="1500" b="0" i="0">
-                <a:solidFill>
-                  <a:srgbClr val="2B2B2B"/>
-                </a:solidFill>
-                <a:latin typeface="Calibri"/>
-              </a:rPr>
-              <a:t>robust to proxy noise; punishes under-prediction of variance.</a:t>
-            </a:r>
-          </a:p>
-          <a:p>
-            <a:pPr algn="l">
-              <a:spcAft>
-                <a:spcPts val="1000"/>
-              </a:spcAft>
-            </a:pPr>
-            <a:r>
-              <a:rPr sz="1500" b="1" i="0">
-                <a:solidFill>
-                  <a:srgbClr val="C8960C"/>
-                </a:solidFill>
-                <a:latin typeface="Calibri"/>
-              </a:rPr>
-              <a:t>RMSE / MAE:  </a:t>
-            </a:r>
-            <a:r>
-              <a:rPr sz="1500" b="0" i="0">
-                <a:solidFill>
-                  <a:srgbClr val="2B2B2B"/>
-                </a:solidFill>
-                <a:latin typeface="Calibri"/>
-              </a:rPr>
-              <a:t>point accuracy on the volatility scale, for interpretability.</a:t>
-            </a:r>
-          </a:p>
-          <a:p>
-            <a:pPr algn="l">
-              <a:spcAft>
-                <a:spcPts val="1000"/>
-              </a:spcAft>
-            </a:pPr>
-            <a:r>
-              <a:rPr sz="1500" b="1" i="0">
-                <a:solidFill>
-                  <a:srgbClr val="C8960C"/>
-                </a:solidFill>
-                <a:latin typeface="Calibri"/>
-              </a:rPr>
-              <a:t>Diebold–Mariano:  </a:t>
-            </a:r>
-            <a:r>
-              <a:rPr sz="1500" b="0" i="0">
-                <a:solidFill>
-                  <a:srgbClr val="2B2B2B"/>
-                </a:solidFill>
-                <a:latin typeface="Calibri"/>
-              </a:rPr>
-              <a:t>tests whether a loss gap is statistically real, not luck.</a:t>
-            </a:r>
-          </a:p>
-        </p:txBody>
-      </p:sp>
-      <p:sp>
-        <p:nvSpPr>
-          <p:cNvPr id="4" name="Rounded Rectangle 3"/>
-          <p:cNvSpPr/>
-          <p:nvPr/>
-        </p:nvSpPr>
-        <p:spPr>
-          <a:xfrm>
-            <a:off x="502920" y="3977639"/>
-            <a:ext cx="2743200" cy="1371600"/>
-          </a:xfrm>
-          <a:prstGeom prst="roundRect">
-            <a:avLst/>
-          </a:prstGeom>
-          <a:solidFill>
-            <a:srgbClr val="F7EFDD"/>
-          </a:solidFill>
-          <a:ln>
-            <a:noFill/>
-          </a:ln>
-          <a:effectLst/>
-        </p:spPr>
-        <p:style>
-          <a:lnRef idx="1">
-            <a:schemeClr val="accent1"/>
-          </a:lnRef>
-          <a:fillRef idx="3">
-            <a:schemeClr val="accent1"/>
-          </a:fillRef>
-          <a:effectRef idx="2">
-            <a:schemeClr val="accent1"/>
-          </a:effectRef>
-          <a:fontRef idx="minor">
-            <a:schemeClr val="lt1"/>
-          </a:fontRef>
-        </p:style>
-        <p:txBody>
-          <a:bodyPr rtlCol="0" anchor="ctr"/>
-          <a:lstStyle/>
-          <a:p>
-            <a:pPr algn="ctr"/>
-          </a:p>
-        </p:txBody>
-      </p:sp>
-      <p:sp>
-        <p:nvSpPr>
-          <p:cNvPr id="5" name="TextBox 4"/>
-          <p:cNvSpPr txBox="1"/>
-          <p:nvPr/>
-        </p:nvSpPr>
-        <p:spPr>
-          <a:xfrm>
-            <a:off x="502920" y="4142231"/>
-            <a:ext cx="2743200" cy="1051560"/>
-          </a:xfrm>
-          <a:prstGeom prst="rect">
-            <a:avLst/>
-          </a:prstGeom>
-          <a:noFill/>
-        </p:spPr>
-        <p:txBody>
-          <a:bodyPr wrap="square" anchor="ctr" lIns="0" rIns="0" tIns="0" bIns="0">
-            <a:spAutoFit/>
-          </a:bodyPr>
-          <a:lstStyle/>
-          <a:p>
-            <a:pPr algn="ctr"/>
-            <a:r>
-              <a:rPr sz="2400" b="1" i="0">
-                <a:solidFill>
-                  <a:srgbClr val="003366"/>
-                </a:solidFill>
-                <a:latin typeface="Calibri"/>
-              </a:rPr>
-              <a:t>QLIKE 1.488</a:t>
-            </a:r>
-          </a:p>
-          <a:p>
-            <a:pPr algn="ctr"/>
-            <a:r>
-              <a:rPr sz="1200" b="0" i="0">
-                <a:solidFill>
-                  <a:srgbClr val="555555"/>
-                </a:solidFill>
-                <a:latin typeface="Calibri"/>
-              </a:rPr>
-              <a:t>GARCH(1,1), best model</a:t>
-            </a:r>
-          </a:p>
-        </p:txBody>
-      </p:sp>
-      <p:sp>
-        <p:nvSpPr>
-          <p:cNvPr id="6" name="Rounded Rectangle 5"/>
-          <p:cNvSpPr/>
-          <p:nvPr/>
-        </p:nvSpPr>
-        <p:spPr>
-          <a:xfrm>
-            <a:off x="3520440" y="3977639"/>
-            <a:ext cx="2743200" cy="1371600"/>
-          </a:xfrm>
-          <a:prstGeom prst="roundRect">
-            <a:avLst/>
-          </a:prstGeom>
-          <a:solidFill>
-            <a:srgbClr val="F7EFDD"/>
-          </a:solidFill>
-          <a:ln>
-            <a:noFill/>
-          </a:ln>
-          <a:effectLst/>
-        </p:spPr>
-        <p:style>
-          <a:lnRef idx="1">
-            <a:schemeClr val="accent1"/>
-          </a:lnRef>
-          <a:fillRef idx="3">
-            <a:schemeClr val="accent1"/>
-          </a:fillRef>
-          <a:effectRef idx="2">
-            <a:schemeClr val="accent1"/>
-          </a:effectRef>
-          <a:fontRef idx="minor">
-            <a:schemeClr val="lt1"/>
-          </a:fontRef>
-        </p:style>
-        <p:txBody>
-          <a:bodyPr rtlCol="0" anchor="ctr"/>
-          <a:lstStyle/>
-          <a:p>
-            <a:pPr algn="ctr"/>
-          </a:p>
-        </p:txBody>
-      </p:sp>
-      <p:sp>
-        <p:nvSpPr>
-          <p:cNvPr id="7" name="TextBox 6"/>
-          <p:cNvSpPr txBox="1"/>
-          <p:nvPr/>
-        </p:nvSpPr>
-        <p:spPr>
-          <a:xfrm>
-            <a:off x="3520440" y="4142231"/>
-            <a:ext cx="2743200" cy="1051560"/>
-          </a:xfrm>
-          <a:prstGeom prst="rect">
-            <a:avLst/>
-          </a:prstGeom>
-          <a:noFill/>
-        </p:spPr>
-        <p:txBody>
-          <a:bodyPr wrap="square" anchor="ctr" lIns="0" rIns="0" tIns="0" bIns="0">
-            <a:spAutoFit/>
-          </a:bodyPr>
-          <a:lstStyle/>
-          <a:p>
-            <a:pPr algn="ctr"/>
-            <a:r>
-              <a:rPr sz="2400" b="1" i="0">
-                <a:solidFill>
-                  <a:srgbClr val="003366"/>
-                </a:solidFill>
-                <a:latin typeface="Calibri"/>
-              </a:rPr>
-              <a:t>p = 0.87</a:t>
-            </a:r>
-          </a:p>
-          <a:p>
-            <a:pPr algn="ctr"/>
-            <a:r>
-              <a:rPr sz="1200" b="0" i="0">
-                <a:solidFill>
-                  <a:srgbClr val="555555"/>
-                </a:solidFill>
-                <a:latin typeface="Calibri"/>
-              </a:rPr>
-              <a:t>GARCH vs EGARCH: not significant</a:t>
-            </a:r>
-          </a:p>
-        </p:txBody>
-      </p:sp>
-      <p:pic>
-        <p:nvPicPr>
-          <p:cNvPr id="8" name="Picture 7" descr="fig_best_vs_realized.png"/>
-          <p:cNvPicPr>
-            <a:picLocks noChangeAspect="1"/>
-          </p:cNvPicPr>
-          <p:nvPr/>
-        </p:nvPicPr>
-        <p:blipFill>
-          <a:blip r:embed="rId2"/>
-          <a:stretch>
-            <a:fillRect/>
-          </a:stretch>
-        </p:blipFill>
-        <p:spPr>
-          <a:xfrm>
-            <a:off x="6172200" y="2834640"/>
-            <a:ext cx="5486400" cy="1828800"/>
-          </a:xfrm>
-          <a:prstGeom prst="rect">
-            <a:avLst/>
-          </a:prstGeom>
-        </p:spPr>
-      </p:pic>
-    </p:spTree>
-  </p:cSld>
-  <p:clrMapOvr>
-    <a:masterClrMapping/>
-  </p:clrMapOvr>
-</p:sld>
-</file>
-
-<file path=ppt/slides/slide8.xml><?xml version="1.0" encoding="utf-8"?>
-<p:sld xmlns:a="http://schemas.openxmlformats.org/drawingml/2006/main" xmlns:p="http://schemas.openxmlformats.org/presentationml/2006/main" xmlns:r="http://schemas.openxmlformats.org/officeDocument/2006/relationships">
-  <p:cSld>
-    <p:spTree>
-      <p:nvGrpSpPr>
-        <p:cNvPr id="1" name=""/>
-        <p:cNvGrpSpPr/>
-        <p:nvPr/>
-      </p:nvGrpSpPr>
-      <p:grpSpPr/>
-      <p:sp>
-        <p:nvSpPr>
-          <p:cNvPr id="2" name="TextBox 1"/>
-          <p:cNvSpPr txBox="1"/>
-          <p:nvPr/>
-        </p:nvSpPr>
-        <p:spPr>
-          <a:xfrm>
-            <a:off x="502920" y="384048"/>
-            <a:ext cx="11155680" cy="914400"/>
-          </a:xfrm>
-          <a:prstGeom prst="rect">
-            <a:avLst/>
-          </a:prstGeom>
-          <a:noFill/>
-        </p:spPr>
-        <p:txBody>
-          <a:bodyPr wrap="square" anchor="t" lIns="0" rIns="0" tIns="0" bIns="0">
-            <a:spAutoFit/>
-          </a:bodyPr>
-          <a:lstStyle/>
-          <a:p>
-            <a:pPr algn="l"/>
-            <a:r>
-              <a:rPr sz="3000" b="1" i="0">
-                <a:solidFill>
-                  <a:srgbClr val="003366"/>
-                </a:solidFill>
-                <a:latin typeface="Calibri"/>
-              </a:rPr>
-              <a:t>Conclusion &amp; Takeaways</a:t>
-            </a:r>
-          </a:p>
-        </p:txBody>
-      </p:sp>
-      <p:sp>
-        <p:nvSpPr>
-          <p:cNvPr id="3" name="TextBox 2"/>
-          <p:cNvSpPr txBox="1"/>
-          <p:nvPr/>
-        </p:nvSpPr>
-        <p:spPr>
-          <a:xfrm>
-            <a:off x="502920" y="1645920"/>
-            <a:ext cx="6583680" cy="4206240"/>
-          </a:xfrm>
-          <a:prstGeom prst="rect">
-            <a:avLst/>
-          </a:prstGeom>
-          <a:noFill/>
-        </p:spPr>
-        <p:txBody>
-          <a:bodyPr wrap="square" anchor="t" lIns="0" rIns="0" tIns="0" bIns="0">
-            <a:spAutoFit/>
-          </a:bodyPr>
-          <a:lstStyle/>
-          <a:p>
-            <a:pPr algn="l">
-              <a:spcAft>
-                <a:spcPts val="900"/>
-              </a:spcAft>
-            </a:pPr>
-            <a:r>
-              <a:rPr sz="1500" b="1" i="0">
-                <a:solidFill>
-                  <a:srgbClr val="C8960C"/>
-                </a:solidFill>
-                <a:latin typeface="Calibri"/>
-              </a:rPr>
-              <a:t>Finding:  </a:t>
-            </a:r>
-            <a:r>
-              <a:rPr sz="1500" b="0" i="0">
-                <a:solidFill>
-                  <a:srgbClr val="2B2B2B"/>
-                </a:solidFill>
-                <a:latin typeface="Calibri"/>
-              </a:rPr>
-              <a:t>a monthly-refit GARCH(1,1) delivers the best QLIKE; no learned model beats the GARCH family on the risk-relevant metric.</a:t>
-            </a:r>
-          </a:p>
-          <a:p>
-            <a:pPr algn="l">
-              <a:spcAft>
-                <a:spcPts val="900"/>
-              </a:spcAft>
-            </a:pPr>
-            <a:r>
-              <a:rPr sz="1500" b="1" i="0">
-                <a:solidFill>
-                  <a:srgbClr val="C8960C"/>
-                </a:solidFill>
-                <a:latin typeface="Calibri"/>
-              </a:rPr>
-              <a:t>Nuance:  </a:t>
-            </a:r>
-            <a:r>
-              <a:rPr sz="1500" b="0" i="0">
-                <a:solidFill>
-                  <a:srgbClr val="2B2B2B"/>
-                </a:solidFill>
-                <a:latin typeface="Calibri"/>
-              </a:rPr>
-              <a:t>XGBoost wins RMSE and MAE — the learned models are competitive, just beaten where it matters.</a:t>
-            </a:r>
-          </a:p>
-          <a:p>
-            <a:pPr algn="l">
-              <a:spcAft>
-                <a:spcPts val="900"/>
-              </a:spcAft>
-            </a:pPr>
-            <a:r>
-              <a:rPr sz="1500" b="1" i="0">
-                <a:solidFill>
-                  <a:srgbClr val="C8960C"/>
-                </a:solidFill>
-                <a:latin typeface="Calibri"/>
-              </a:rPr>
-              <a:t>Why:  </a:t>
-            </a:r>
-            <a:r>
-              <a:rPr sz="1500" b="0" i="0">
-                <a:solidFill>
-                  <a:srgbClr val="2B2B2B"/>
-                </a:solidFill>
-                <a:latin typeface="Calibri"/>
-              </a:rPr>
-              <a:t>the signal is one-dimensional and small-data; GARCH is shaped exactly for it and fit by maximum likelihood.</a:t>
-            </a:r>
-          </a:p>
-          <a:p>
-            <a:pPr algn="l">
-              <a:spcAft>
-                <a:spcPts val="900"/>
-              </a:spcAft>
-            </a:pPr>
-            <a:r>
-              <a:rPr sz="1500" b="1" i="0">
-                <a:solidFill>
-                  <a:srgbClr val="C8960C"/>
-                </a:solidFill>
-                <a:latin typeface="Calibri"/>
-              </a:rPr>
-              <a:t>Learned:  </a:t>
-            </a:r>
-            <a:r>
-              <a:rPr sz="1500" b="0" i="0">
-                <a:solidFill>
-                  <a:srgbClr val="2B2B2B"/>
-                </a:solidFill>
-                <a:latin typeface="Calibri"/>
-              </a:rPr>
-              <a:t>a leak-free walk-forward harness matters more than model complexity, and the metric defines what “better” means.</a:t>
-            </a:r>
-          </a:p>
-          <a:p>
-            <a:pPr algn="l">
-              <a:spcAft>
-                <a:spcPts val="900"/>
-              </a:spcAft>
-            </a:pPr>
-            <a:r>
-              <a:rPr sz="1500" b="1" i="0">
-                <a:solidFill>
-                  <a:srgbClr val="C8960C"/>
-                </a:solidFill>
-                <a:latin typeface="Calibri"/>
-              </a:rPr>
-              <a:t>Future work:  </a:t>
-            </a:r>
-            <a:r>
-              <a:rPr sz="1500" b="0" i="0">
-                <a:solidFill>
-                  <a:srgbClr val="2B2B2B"/>
-                </a:solidFill>
-                <a:latin typeface="Calibri"/>
-              </a:rPr>
-              <a:t>intraday realized variance, exogenous features (VIX), multi-asset pooling, hybrid GARCH+ML.</a:t>
-            </a:r>
-          </a:p>
-        </p:txBody>
-      </p:sp>
-      <p:sp>
-        <p:nvSpPr>
-          <p:cNvPr id="4" name="Rounded Rectangle 3"/>
-          <p:cNvSpPr/>
-          <p:nvPr/>
-        </p:nvSpPr>
-        <p:spPr>
-          <a:xfrm>
-            <a:off x="7360920" y="1920240"/>
-            <a:ext cx="4251960" cy="2103120"/>
-          </a:xfrm>
-          <a:prstGeom prst="roundRect">
-            <a:avLst/>
-          </a:prstGeom>
-          <a:solidFill>
-            <a:srgbClr val="ECF1F6"/>
-          </a:solidFill>
-          <a:ln>
-            <a:noFill/>
-          </a:ln>
-          <a:effectLst/>
-        </p:spPr>
-        <p:style>
-          <a:lnRef idx="1">
-            <a:schemeClr val="accent1"/>
-          </a:lnRef>
-          <a:fillRef idx="3">
-            <a:schemeClr val="accent1"/>
-          </a:fillRef>
-          <a:effectRef idx="2">
-            <a:schemeClr val="accent1"/>
-          </a:effectRef>
-          <a:fontRef idx="minor">
-            <a:schemeClr val="lt1"/>
-          </a:fontRef>
-        </p:style>
-        <p:txBody>
-          <a:bodyPr rtlCol="0" anchor="ctr"/>
-          <a:lstStyle/>
-          <a:p>
-            <a:pPr algn="ctr"/>
-          </a:p>
-        </p:txBody>
-      </p:sp>
-      <p:sp>
-        <p:nvSpPr>
-          <p:cNvPr id="5" name="TextBox 4"/>
-          <p:cNvSpPr txBox="1"/>
-          <p:nvPr/>
-        </p:nvSpPr>
-        <p:spPr>
-          <a:xfrm>
-            <a:off x="7589520" y="2148840"/>
-            <a:ext cx="3840480" cy="1737360"/>
-          </a:xfrm>
-          <a:prstGeom prst="rect">
-            <a:avLst/>
-          </a:prstGeom>
-          <a:noFill/>
-        </p:spPr>
-        <p:txBody>
-          <a:bodyPr wrap="square" anchor="t" lIns="0" rIns="0" tIns="0" bIns="0">
-            <a:spAutoFit/>
-          </a:bodyPr>
-          <a:lstStyle/>
-          <a:p>
-            <a:pPr>
-              <a:spcAft>
-                <a:spcPts val="800"/>
-              </a:spcAft>
-            </a:pPr>
-            <a:r>
-              <a:rPr sz="1600" b="1" i="0">
-                <a:solidFill>
-                  <a:srgbClr val="003366"/>
-                </a:solidFill>
-                <a:latin typeface="Calibri"/>
-              </a:rPr>
-              <a:t>Project artifacts</a:t>
-            </a:r>
-          </a:p>
-          <a:p>
-            <a:pPr>
-              <a:spcAft>
-                <a:spcPts val="600"/>
-              </a:spcAft>
-            </a:pPr>
-            <a:r>
-              <a:rPr sz="1300" b="1" i="0">
-                <a:solidFill>
-                  <a:srgbClr val="C8960C"/>
-                </a:solidFill>
-                <a:latin typeface="Calibri"/>
-              </a:rPr>
-              <a:t>Code: </a:t>
-            </a:r>
-            <a:r>
-              <a:rPr sz="1300" b="0" i="0">
-                <a:solidFill>
-                  <a:srgbClr val="2B2B2B"/>
-                </a:solidFill>
-                <a:latin typeface="Calibri"/>
-              </a:rPr>
-              <a:t>github.com/iitgF/T9</a:t>
-            </a:r>
-          </a:p>
-          <a:p>
-            <a:pPr>
-              <a:spcAft>
-                <a:spcPts val="600"/>
-              </a:spcAft>
-            </a:pPr>
-            <a:r>
-              <a:rPr sz="1300" b="1" i="0">
-                <a:solidFill>
-                  <a:srgbClr val="C8960C"/>
-                </a:solidFill>
-                <a:latin typeface="Calibri"/>
-              </a:rPr>
-              <a:t>Report: </a:t>
-            </a:r>
-            <a:r>
-              <a:rPr sz="1300" b="0" i="0">
-                <a:solidFill>
-                  <a:srgbClr val="2B2B2B"/>
-                </a:solidFill>
-                <a:latin typeface="Calibri"/>
-              </a:rPr>
-              <a:t>LaTeX (Overleaf)</a:t>
-            </a:r>
-          </a:p>
-          <a:p>
-            <a:pPr>
-              <a:spcAft>
-                <a:spcPts val="600"/>
-              </a:spcAft>
-            </a:pPr>
-            <a:r>
-              <a:rPr sz="1300" b="1" i="0">
-                <a:solidFill>
-                  <a:srgbClr val="C8960C"/>
-                </a:solidFill>
-                <a:latin typeface="Calibri"/>
-              </a:rPr>
-              <a:t>Notebook: </a:t>
-            </a:r>
-            <a:r>
-              <a:rPr sz="1300" b="0" i="0">
-                <a:solidFill>
-                  <a:srgbClr val="2B2B2B"/>
-                </a:solidFill>
-                <a:latin typeface="Calibri"/>
-              </a:rPr>
-              <a:t>consolidated, runs end-to-end</a:t>
+              <a:t>All models track the same clusters. GARCH(1,1) wins on QLIKE; XGBoost has the best RMSE/MAE but ranks 5th on QLIKE.</a:t>
             </a:r>
           </a:p>
         </p:txBody>

</xml_diff>

<commit_message>
Extend sample to 2026-06-30 and refresh all results
Re-run the full pipeline on 2008-01-01 to 2026-06-30 (4,650 returns;
test window 2020-12-07 to 2026-06-29, 1,395 days). The story changes:
EGARCH(1,1) now wins on QLIKE (1.504), tied with GJR-GARCH, and the
leverage models significantly beat plain GARCH (DM p<0.0001) on a test
window containing the 2022 bear market and the April-2025 tariff shock.
The LSTM ranks third, ahead of plain GARCH and statistically tied with
the winner. Update figures, both reports, README, notebooks, and the
presentation deck accordingly.

Co-Authored-By: Claude Opus 4.8 <noreply@anthropic.com>
</commit_message>
<xml_diff>
--- a/Project_Video_Presentation.pptx
+++ b/Project_Video_Presentation.pptx
@@ -4918,7 +4918,7 @@
                 </a:solidFill>
                 <a:latin typeface="Calibri"/>
               </a:rPr>
-              <a:t>GARCH(1,1)  </a:t>
+              <a:t>EGARCH(1,1)  </a:t>
             </a:r>
             <a:r>
               <a:rPr sz="1500" b="0" i="0">
@@ -4927,7 +4927,7 @@
                 </a:solidFill>
                 <a:latin typeface="Calibri"/>
               </a:rPr>
-              <a:t>gives the lowest QLIKE of all eight models.</a:t>
+              <a:t>gives the lowest QLIKE; GJR-GARCH is statistically tied (p = 0.47).</a:t>
             </a:r>
           </a:p>
           <a:p>
@@ -4943,7 +4943,7 @@
                 </a:solidFill>
                 <a:latin typeface="Calibri"/>
               </a:rPr>
-              <a:t>But  </a:t>
+              <a:t>Leverage matters:  </a:t>
             </a:r>
             <a:r>
               <a:rPr sz="1500" b="0" i="0">
@@ -4952,7 +4952,7 @@
                 </a:solidFill>
                 <a:latin typeface="Calibri"/>
               </a:rPr>
-              <a:t>the top three GARCH-family models are statistically tied.</a:t>
+              <a:t>both beat plain GARCH(1,1) decisively (p &lt; 0.0001) on this window.</a:t>
             </a:r>
           </a:p>
           <a:p>
@@ -4968,7 +4968,7 @@
                 </a:solidFill>
                 <a:latin typeface="Calibri"/>
               </a:rPr>
-              <a:t>Diebold–Mariano:  </a:t>
+              <a:t>LSTM:  </a:t>
             </a:r>
             <a:r>
               <a:rPr sz="1500" b="0" i="0">
@@ -4977,7 +4977,7 @@
                 </a:solidFill>
                 <a:latin typeface="Calibri"/>
               </a:rPr>
-              <a:t>GARCH(1,1) vs EGARCH(1,1) gives p = 0.87, not significant.</a:t>
+              <a:t>third place, ahead of plain GARCH, and statistically tied with the winner (p = 0.19).</a:t>
             </a:r>
           </a:p>
         </p:txBody>
@@ -5056,7 +5056,7 @@
                 </a:solidFill>
                 <a:latin typeface="Calibri"/>
               </a:rPr>
-              <a:t>QLIKE 1.488</a:t>
+              <a:t>QLIKE 1.504</a:t>
             </a:r>
           </a:p>
           <a:p>
@@ -5068,7 +5068,7 @@
                 </a:solidFill>
                 <a:latin typeface="Calibri"/>
               </a:rPr>
-              <a:t>GARCH(1,1), best model</a:t>
+              <a:t>EGARCH(1,1), best model</a:t>
             </a:r>
           </a:p>
         </p:txBody>
@@ -5147,7 +5147,7 @@
                 </a:solidFill>
                 <a:latin typeface="Calibri"/>
               </a:rPr>
-              <a:t>p = 0.87</a:t>
+              <a:t>p &lt; 0.0001</a:t>
             </a:r>
           </a:p>
           <a:p>
@@ -5159,7 +5159,7 @@
                 </a:solidFill>
                 <a:latin typeface="Calibri"/>
               </a:rPr>
-              <a:t>GARCH vs EGARCH: not significant</a:t>
+              <a:t>EGARCH vs plain GARCH: significant</a:t>
             </a:r>
           </a:p>
         </p:txBody>
@@ -5180,8 +5180,8 @@
         </p:blipFill>
         <p:spPr>
           <a:xfrm>
-            <a:off x="6172200" y="2834640"/>
-            <a:ext cx="5486400" cy="1828800"/>
+            <a:off x="6172200" y="2849251"/>
+            <a:ext cx="5486400" cy="1799576"/>
           </a:xfrm>
           <a:prstGeom prst="rect">
             <a:avLst/>
@@ -5235,7 +5235,7 @@
                 </a:solidFill>
                 <a:latin typeface="Calibri"/>
               </a:rPr>
-              <a:t>Why Is GARCH So Hard to Beat?</a:t>
+              <a:t>Why Do the Leverage Models Win?</a:t>
             </a:r>
           </a:p>
         </p:txBody>
@@ -5274,7 +5274,7 @@
                 </a:solidFill>
                 <a:latin typeface="Calibri"/>
               </a:rPr>
-              <a:t>Signal shape:  </a:t>
+              <a:t>Leverage effect:  </a:t>
             </a:r>
             <a:r>
               <a:rPr sz="1600" b="0" i="0">
@@ -5283,7 +5283,7 @@
                 </a:solidFill>
                 <a:latin typeface="Calibri"/>
               </a:rPr>
-              <a:t>the exploitable signal is one-dimensional, and GARCH is built exactly for it with three parameters.</a:t>
+              <a:t>the test window is dominated by two sharp crashes (2022 and April 2025), and the leverage term turns a big fall directly into higher next-day variance.</a:t>
             </a:r>
           </a:p>
           <a:p>
@@ -5308,7 +5308,7 @@
                 </a:solidFill>
                 <a:latin typeface="Calibri"/>
               </a:rPr>
-              <a:t>GARCH is fit by maximum likelihood on variance; the learned models train on a smoother substitute target.</a:t>
+              <a:t>the GARCH family is fit by maximum likelihood on variance; the learned models train on a smoother substitute target.</a:t>
             </a:r>
           </a:p>
           <a:p>
@@ -5333,7 +5333,7 @@
                 </a:solidFill>
                 <a:latin typeface="Calibri"/>
               </a:rPr>
-              <a:t>roughly 3,000 noisy training days favours simple models over neural networks.</a:t>
+              <a:t>roughly 3,250 noisy training days favours simple recursions over neural networks.</a:t>
             </a:r>
           </a:p>
           <a:p>
@@ -5358,7 +5358,7 @@
                 </a:solidFill>
                 <a:latin typeface="Calibri"/>
               </a:rPr>
-              <a:t>it rewards fast reactions to spikes, and GARCH reacts the very next day.</a:t>
+              <a:t>it rewards fast reactions to spikes, and the GARCH recursion reacts the very next day.</a:t>
             </a:r>
           </a:p>
           <a:p>
@@ -5483,7 +5483,7 @@
                 </a:solidFill>
                 <a:latin typeface="Calibri"/>
               </a:rPr>
-              <a:t>no. A monthly-refit GARCH(1,1) gives the best QLIKE; no learned model beats the GARCH family where it matters.</a:t>
+              <a:t>no. A monthly-refit EGARCH(1,1) gives the best QLIKE; no learned model beats the leverage GARCH family where it matters.</a:t>
             </a:r>
           </a:p>
           <a:p>
@@ -5508,7 +5508,32 @@
                 </a:solidFill>
                 <a:latin typeface="Calibri"/>
               </a:rPr>
-              <a:t>XGBoost wins RMSE and MAE. The learned models are competitive, just beaten on the risk-relevant metric.</a:t>
+              <a:t>the LSTM ranks third, ahead of plain GARCH, and is statistically tied with the winner; LSTM and XGBoost take the best RMSE and MAE.</a:t>
+            </a:r>
+          </a:p>
+          <a:p>
+            <a:pPr algn="l">
+              <a:spcAft>
+                <a:spcPts val="1200"/>
+              </a:spcAft>
+            </a:pPr>
+            <a:r>
+              <a:rPr sz="1600" b="1" i="0">
+                <a:solidFill>
+                  <a:srgbClr val="C8960C"/>
+                </a:solidFill>
+                <a:latin typeface="Calibri"/>
+              </a:rPr>
+              <a:t>Leverage matters:  </a:t>
+            </a:r>
+            <a:r>
+              <a:rPr sz="1600" b="0" i="0">
+                <a:solidFill>
+                  <a:srgbClr val="2B2B2B"/>
+                </a:solidFill>
+                <a:latin typeface="Calibri"/>
+              </a:rPr>
+              <a:t>on a window with two asymmetric crashes, EGARCH and GJR significantly beat plain GARCH.</a:t>
             </a:r>
           </a:p>
           <a:p>
@@ -6548,7 +6573,7 @@
                 </a:solidFill>
                 <a:latin typeface="Calibri"/>
               </a:rPr>
-              <a:t>4,277</a:t>
+              <a:t>4,650</a:t>
             </a:r>
           </a:p>
           <a:p>
@@ -6639,7 +6664,7 @@
                 </a:solidFill>
                 <a:latin typeface="Calibri"/>
               </a:rPr>
-              <a:t>2008–2024</a:t>
+              <a:t>2008–2026</a:t>
             </a:r>
           </a:p>
           <a:p>
@@ -6651,7 +6676,7 @@
                 </a:solidFill>
                 <a:latin typeface="Calibri"/>
               </a:rPr>
-              <a:t>17 years</a:t>
+              <a:t>18.5 years</a:t>
             </a:r>
           </a:p>
         </p:txBody>
@@ -6821,7 +6846,7 @@
                 </a:solidFill>
                 <a:latin typeface="Calibri"/>
               </a:rPr>
-              <a:t>1,284</a:t>
+              <a:t>1,395</a:t>
             </a:r>
           </a:p>
           <a:p>
@@ -6931,7 +6956,7 @@
                 </a:solidFill>
                 <a:latin typeface="Calibri"/>
               </a:rPr>
-              <a:t>the final 30% (2019-11-21 to 2024-12-30), shared by every model.</a:t>
+              <a:t>the final 30% (2020-12-07 to 2026-06-29), shared by every model.</a:t>
             </a:r>
           </a:p>
           <a:p>
@@ -6956,7 +6981,7 @@
                 </a:solidFill>
                 <a:latin typeface="Calibri"/>
               </a:rPr>
-              <a:t>the window contains the COVID-2020 crash and the 2022 bear market.</a:t>
+              <a:t>the window contains the 2022 bear market and the April-2025 tariff shock.</a:t>
             </a:r>
           </a:p>
         </p:txBody>
@@ -8354,7 +8379,7 @@
                 </a:solidFill>
                 <a:latin typeface="Calibri"/>
               </a:rPr>
-              <a:t>Out-of-sample, 1,284 days, sorted by QLIKE (lower = better)</a:t>
+              <a:t>Out-of-sample, 1,395 days, sorted by QLIKE (lower = better)</a:t>
             </a:r>
           </a:p>
         </p:txBody>
@@ -8491,7 +8516,7 @@
                           </a:solidFill>
                           <a:latin typeface="Calibri"/>
                         </a:rPr>
-                        <a:t>GARCH(1,1)</a:t>
+                        <a:t>EGARCH(1,1)</a:t>
                       </a:r>
                     </a:p>
                   </a:txBody>
@@ -8514,7 +8539,7 @@
                           </a:solidFill>
                           <a:latin typeface="Calibri"/>
                         </a:rPr>
-                        <a:t>0.00887</a:t>
+                        <a:t>0.00728</a:t>
                       </a:r>
                     </a:p>
                   </a:txBody>
@@ -8537,7 +8562,7 @@
                           </a:solidFill>
                           <a:latin typeface="Calibri"/>
                         </a:rPr>
-                        <a:t>0.00633</a:t>
+                        <a:t>0.00556</a:t>
                       </a:r>
                     </a:p>
                   </a:txBody>
@@ -8560,7 +8585,7 @@
                           </a:solidFill>
                           <a:latin typeface="Calibri"/>
                         </a:rPr>
-                        <a:t>1.4879</a:t>
+                        <a:t>1.5042</a:t>
                       </a:r>
                     </a:p>
                   </a:txBody>
@@ -8585,7 +8610,7 @@
                           </a:solidFill>
                           <a:latin typeface="Calibri"/>
                         </a:rPr>
-                        <a:t>EGARCH(1,1)</a:t>
+                        <a:t>GJR-GARCH(1,1)</a:t>
                       </a:r>
                     </a:p>
                   </a:txBody>
@@ -8608,7 +8633,7 @@
                           </a:solidFill>
                           <a:latin typeface="Calibri"/>
                         </a:rPr>
-                        <a:t>0.00852</a:t>
+                        <a:t>0.00731</a:t>
                       </a:r>
                     </a:p>
                   </a:txBody>
@@ -8631,7 +8656,7 @@
                           </a:solidFill>
                           <a:latin typeface="Calibri"/>
                         </a:rPr>
-                        <a:t>0.00603</a:t>
+                        <a:t>0.00554</a:t>
                       </a:r>
                     </a:p>
                   </a:txBody>
@@ -8654,383 +8679,7 @@
                           </a:solidFill>
                           <a:latin typeface="Calibri"/>
                         </a:rPr>
-                        <a:t>1.4943</a:t>
-                      </a:r>
-                    </a:p>
-                  </a:txBody>
-                  <a:tcPr marL="73152" marR="45720" marT="18288" marB="18288" anchor="ctr">
-                    <a:solidFill>
-                      <a:srgbClr val="ECF1F6"/>
-                    </a:solidFill>
-                  </a:tcPr>
-                </a:tc>
-              </a:tr>
-              <a:tr h="426720">
-                <a:tc>
-                  <a:txBody>
-                    <a:bodyPr/>
-                    <a:lstStyle/>
-                    <a:p>
-                      <a:pPr algn="l"/>
-                      <a:r>
-                        <a:rPr sz="1150" b="0">
-                          <a:solidFill>
-                            <a:srgbClr val="2B2B2B"/>
-                          </a:solidFill>
-                          <a:latin typeface="Calibri"/>
-                        </a:rPr>
-                        <a:t>GJR-GARCH(1,1)</a:t>
-                      </a:r>
-                    </a:p>
-                  </a:txBody>
-                  <a:tcPr marL="73152" marR="45720" marT="18288" marB="18288" anchor="ctr">
-                    <a:solidFill>
-                      <a:srgbClr val="FFFFFF"/>
-                    </a:solidFill>
-                  </a:tcPr>
-                </a:tc>
-                <a:tc>
-                  <a:txBody>
-                    <a:bodyPr/>
-                    <a:lstStyle/>
-                    <a:p>
-                      <a:pPr algn="ctr"/>
-                      <a:r>
-                        <a:rPr sz="1150" b="0">
-                          <a:solidFill>
-                            <a:srgbClr val="2B2B2B"/>
-                          </a:solidFill>
-                          <a:latin typeface="Calibri"/>
-                        </a:rPr>
-                        <a:t>0.00881</a:t>
-                      </a:r>
-                    </a:p>
-                  </a:txBody>
-                  <a:tcPr marL="73152" marR="45720" marT="18288" marB="18288" anchor="ctr">
-                    <a:solidFill>
-                      <a:srgbClr val="FFFFFF"/>
-                    </a:solidFill>
-                  </a:tcPr>
-                </a:tc>
-                <a:tc>
-                  <a:txBody>
-                    <a:bodyPr/>
-                    <a:lstStyle/>
-                    <a:p>
-                      <a:pPr algn="ctr"/>
-                      <a:r>
-                        <a:rPr sz="1150" b="0">
-                          <a:solidFill>
-                            <a:srgbClr val="2B2B2B"/>
-                          </a:solidFill>
-                          <a:latin typeface="Calibri"/>
-                        </a:rPr>
-                        <a:t>0.00611</a:t>
-                      </a:r>
-                    </a:p>
-                  </a:txBody>
-                  <a:tcPr marL="73152" marR="45720" marT="18288" marB="18288" anchor="ctr">
-                    <a:solidFill>
-                      <a:srgbClr val="FFFFFF"/>
-                    </a:solidFill>
-                  </a:tcPr>
-                </a:tc>
-                <a:tc>
-                  <a:txBody>
-                    <a:bodyPr/>
-                    <a:lstStyle/>
-                    <a:p>
-                      <a:pPr algn="ctr"/>
-                      <a:r>
-                        <a:rPr sz="1150" b="0">
-                          <a:solidFill>
-                            <a:srgbClr val="2B2B2B"/>
-                          </a:solidFill>
-                          <a:latin typeface="Calibri"/>
-                        </a:rPr>
-                        <a:t>1.4974</a:t>
-                      </a:r>
-                    </a:p>
-                  </a:txBody>
-                  <a:tcPr marL="73152" marR="45720" marT="18288" marB="18288" anchor="ctr">
-                    <a:solidFill>
-                      <a:srgbClr val="FFFFFF"/>
-                    </a:solidFill>
-                  </a:tcPr>
-                </a:tc>
-              </a:tr>
-              <a:tr h="426720">
-                <a:tc>
-                  <a:txBody>
-                    <a:bodyPr/>
-                    <a:lstStyle/>
-                    <a:p>
-                      <a:pPr algn="l"/>
-                      <a:r>
-                        <a:rPr sz="1150" b="0">
-                          <a:solidFill>
-                            <a:srgbClr val="2B2B2B"/>
-                          </a:solidFill>
-                          <a:latin typeface="Calibri"/>
-                        </a:rPr>
-                        <a:t>EWMA(0.94)</a:t>
-                      </a:r>
-                    </a:p>
-                  </a:txBody>
-                  <a:tcPr marL="73152" marR="45720" marT="18288" marB="18288" anchor="ctr">
-                    <a:solidFill>
-                      <a:srgbClr val="ECF1F6"/>
-                    </a:solidFill>
-                  </a:tcPr>
-                </a:tc>
-                <a:tc>
-                  <a:txBody>
-                    <a:bodyPr/>
-                    <a:lstStyle/>
-                    <a:p>
-                      <a:pPr algn="ctr"/>
-                      <a:r>
-                        <a:rPr sz="1150" b="0">
-                          <a:solidFill>
-                            <a:srgbClr val="2B2B2B"/>
-                          </a:solidFill>
-                          <a:latin typeface="Calibri"/>
-                        </a:rPr>
-                        <a:t>0.00934</a:t>
-                      </a:r>
-                    </a:p>
-                  </a:txBody>
-                  <a:tcPr marL="73152" marR="45720" marT="18288" marB="18288" anchor="ctr">
-                    <a:solidFill>
-                      <a:srgbClr val="ECF1F6"/>
-                    </a:solidFill>
-                  </a:tcPr>
-                </a:tc>
-                <a:tc>
-                  <a:txBody>
-                    <a:bodyPr/>
-                    <a:lstStyle/>
-                    <a:p>
-                      <a:pPr algn="ctr"/>
-                      <a:r>
-                        <a:rPr sz="1150" b="0">
-                          <a:solidFill>
-                            <a:srgbClr val="2B2B2B"/>
-                          </a:solidFill>
-                          <a:latin typeface="Calibri"/>
-                        </a:rPr>
-                        <a:t>0.00657</a:t>
-                      </a:r>
-                    </a:p>
-                  </a:txBody>
-                  <a:tcPr marL="73152" marR="45720" marT="18288" marB="18288" anchor="ctr">
-                    <a:solidFill>
-                      <a:srgbClr val="ECF1F6"/>
-                    </a:solidFill>
-                  </a:tcPr>
-                </a:tc>
-                <a:tc>
-                  <a:txBody>
-                    <a:bodyPr/>
-                    <a:lstStyle/>
-                    <a:p>
-                      <a:pPr algn="ctr"/>
-                      <a:r>
-                        <a:rPr sz="1150" b="0">
-                          <a:solidFill>
-                            <a:srgbClr val="2B2B2B"/>
-                          </a:solidFill>
-                          <a:latin typeface="Calibri"/>
-                        </a:rPr>
-                        <a:t>1.5161</a:t>
-                      </a:r>
-                    </a:p>
-                  </a:txBody>
-                  <a:tcPr marL="73152" marR="45720" marT="18288" marB="18288" anchor="ctr">
-                    <a:solidFill>
-                      <a:srgbClr val="ECF1F6"/>
-                    </a:solidFill>
-                  </a:tcPr>
-                </a:tc>
-              </a:tr>
-              <a:tr h="426720">
-                <a:tc>
-                  <a:txBody>
-                    <a:bodyPr/>
-                    <a:lstStyle/>
-                    <a:p>
-                      <a:pPr algn="l"/>
-                      <a:r>
-                        <a:rPr sz="1150" b="0">
-                          <a:solidFill>
-                            <a:srgbClr val="2B2B2B"/>
-                          </a:solidFill>
-                          <a:latin typeface="Calibri"/>
-                        </a:rPr>
-                        <a:t>XGBoost</a:t>
-                      </a:r>
-                    </a:p>
-                  </a:txBody>
-                  <a:tcPr marL="73152" marR="45720" marT="18288" marB="18288" anchor="ctr">
-                    <a:solidFill>
-                      <a:srgbClr val="FFFFFF"/>
-                    </a:solidFill>
-                  </a:tcPr>
-                </a:tc>
-                <a:tc>
-                  <a:txBody>
-                    <a:bodyPr/>
-                    <a:lstStyle/>
-                    <a:p>
-                      <a:pPr algn="ctr"/>
-                      <a:r>
-                        <a:rPr sz="1150" b="0">
-                          <a:solidFill>
-                            <a:srgbClr val="2B2B2B"/>
-                          </a:solidFill>
-                          <a:latin typeface="Calibri"/>
-                        </a:rPr>
-                        <a:t>0.00816</a:t>
-                      </a:r>
-                    </a:p>
-                  </a:txBody>
-                  <a:tcPr marL="73152" marR="45720" marT="18288" marB="18288" anchor="ctr">
-                    <a:solidFill>
-                      <a:srgbClr val="FFFFFF"/>
-                    </a:solidFill>
-                  </a:tcPr>
-                </a:tc>
-                <a:tc>
-                  <a:txBody>
-                    <a:bodyPr/>
-                    <a:lstStyle/>
-                    <a:p>
-                      <a:pPr algn="ctr"/>
-                      <a:r>
-                        <a:rPr sz="1150" b="0">
-                          <a:solidFill>
-                            <a:srgbClr val="2B2B2B"/>
-                          </a:solidFill>
-                          <a:latin typeface="Calibri"/>
-                        </a:rPr>
-                        <a:t>0.00547</a:t>
-                      </a:r>
-                    </a:p>
-                  </a:txBody>
-                  <a:tcPr marL="73152" marR="45720" marT="18288" marB="18288" anchor="ctr">
-                    <a:solidFill>
-                      <a:srgbClr val="FFFFFF"/>
-                    </a:solidFill>
-                  </a:tcPr>
-                </a:tc>
-                <a:tc>
-                  <a:txBody>
-                    <a:bodyPr/>
-                    <a:lstStyle/>
-                    <a:p>
-                      <a:pPr algn="ctr"/>
-                      <a:r>
-                        <a:rPr sz="1150" b="0">
-                          <a:solidFill>
-                            <a:srgbClr val="2B2B2B"/>
-                          </a:solidFill>
-                          <a:latin typeface="Calibri"/>
-                        </a:rPr>
-                        <a:t>1.5567</a:t>
-                      </a:r>
-                    </a:p>
-                  </a:txBody>
-                  <a:tcPr marL="73152" marR="45720" marT="18288" marB="18288" anchor="ctr">
-                    <a:solidFill>
-                      <a:srgbClr val="FFFFFF"/>
-                    </a:solidFill>
-                  </a:tcPr>
-                </a:tc>
-              </a:tr>
-              <a:tr h="426720">
-                <a:tc>
-                  <a:txBody>
-                    <a:bodyPr/>
-                    <a:lstStyle/>
-                    <a:p>
-                      <a:pPr algn="l"/>
-                      <a:r>
-                        <a:rPr sz="1150" b="0">
-                          <a:solidFill>
-                            <a:srgbClr val="2B2B2B"/>
-                          </a:solidFill>
-                          <a:latin typeface="Calibri"/>
-                        </a:rPr>
-                        <a:t>Rolling(21)</a:t>
-                      </a:r>
-                    </a:p>
-                  </a:txBody>
-                  <a:tcPr marL="73152" marR="45720" marT="18288" marB="18288" anchor="ctr">
-                    <a:solidFill>
-                      <a:srgbClr val="ECF1F6"/>
-                    </a:solidFill>
-                  </a:tcPr>
-                </a:tc>
-                <a:tc>
-                  <a:txBody>
-                    <a:bodyPr/>
-                    <a:lstStyle/>
-                    <a:p>
-                      <a:pPr algn="ctr"/>
-                      <a:r>
-                        <a:rPr sz="1150" b="0">
-                          <a:solidFill>
-                            <a:srgbClr val="2B2B2B"/>
-                          </a:solidFill>
-                          <a:latin typeface="Calibri"/>
-                        </a:rPr>
-                        <a:t>0.00948</a:t>
-                      </a:r>
-                    </a:p>
-                  </a:txBody>
-                  <a:tcPr marL="73152" marR="45720" marT="18288" marB="18288" anchor="ctr">
-                    <a:solidFill>
-                      <a:srgbClr val="ECF1F6"/>
-                    </a:solidFill>
-                  </a:tcPr>
-                </a:tc>
-                <a:tc>
-                  <a:txBody>
-                    <a:bodyPr/>
-                    <a:lstStyle/>
-                    <a:p>
-                      <a:pPr algn="ctr"/>
-                      <a:r>
-                        <a:rPr sz="1150" b="0">
-                          <a:solidFill>
-                            <a:srgbClr val="2B2B2B"/>
-                          </a:solidFill>
-                          <a:latin typeface="Calibri"/>
-                        </a:rPr>
-                        <a:t>0.00646</a:t>
-                      </a:r>
-                    </a:p>
-                  </a:txBody>
-                  <a:tcPr marL="73152" marR="45720" marT="18288" marB="18288" anchor="ctr">
-                    <a:solidFill>
-                      <a:srgbClr val="ECF1F6"/>
-                    </a:solidFill>
-                  </a:tcPr>
-                </a:tc>
-                <a:tc>
-                  <a:txBody>
-                    <a:bodyPr/>
-                    <a:lstStyle/>
-                    <a:p>
-                      <a:pPr algn="ctr"/>
-                      <a:r>
-                        <a:rPr sz="1150" b="0">
-                          <a:solidFill>
-                            <a:srgbClr val="2B2B2B"/>
-                          </a:solidFill>
-                          <a:latin typeface="Calibri"/>
-                        </a:rPr>
-                        <a:t>1.5798</a:t>
+                        <a:t>1.5091</a:t>
                       </a:r>
                     </a:p>
                   </a:txBody>
@@ -9078,7 +8727,7 @@
                           </a:solidFill>
                           <a:latin typeface="Calibri"/>
                         </a:rPr>
-                        <a:t>0.00965</a:t>
+                        <a:t>0.00686</a:t>
                       </a:r>
                     </a:p>
                   </a:txBody>
@@ -9101,7 +8750,7 @@
                           </a:solidFill>
                           <a:latin typeface="Calibri"/>
                         </a:rPr>
-                        <a:t>0.00570</a:t>
+                        <a:t>0.00499</a:t>
                       </a:r>
                     </a:p>
                   </a:txBody>
@@ -9124,7 +8773,383 @@
                           </a:solidFill>
                           <a:latin typeface="Calibri"/>
                         </a:rPr>
-                        <a:t>1.5915</a:t>
+                        <a:t>1.5287</a:t>
+                      </a:r>
+                    </a:p>
+                  </a:txBody>
+                  <a:tcPr marL="73152" marR="45720" marT="18288" marB="18288" anchor="ctr">
+                    <a:solidFill>
+                      <a:srgbClr val="FFFFFF"/>
+                    </a:solidFill>
+                  </a:tcPr>
+                </a:tc>
+              </a:tr>
+              <a:tr h="426720">
+                <a:tc>
+                  <a:txBody>
+                    <a:bodyPr/>
+                    <a:lstStyle/>
+                    <a:p>
+                      <a:pPr algn="l"/>
+                      <a:r>
+                        <a:rPr sz="1150" b="0">
+                          <a:solidFill>
+                            <a:srgbClr val="2B2B2B"/>
+                          </a:solidFill>
+                          <a:latin typeface="Calibri"/>
+                        </a:rPr>
+                        <a:t>GARCH(1,1)</a:t>
+                      </a:r>
+                    </a:p>
+                  </a:txBody>
+                  <a:tcPr marL="73152" marR="45720" marT="18288" marB="18288" anchor="ctr">
+                    <a:solidFill>
+                      <a:srgbClr val="ECF1F6"/>
+                    </a:solidFill>
+                  </a:tcPr>
+                </a:tc>
+                <a:tc>
+                  <a:txBody>
+                    <a:bodyPr/>
+                    <a:lstStyle/>
+                    <a:p>
+                      <a:pPr algn="ctr"/>
+                      <a:r>
+                        <a:rPr sz="1150" b="0">
+                          <a:solidFill>
+                            <a:srgbClr val="2B2B2B"/>
+                          </a:solidFill>
+                          <a:latin typeface="Calibri"/>
+                        </a:rPr>
+                        <a:t>0.00751</a:t>
+                      </a:r>
+                    </a:p>
+                  </a:txBody>
+                  <a:tcPr marL="73152" marR="45720" marT="18288" marB="18288" anchor="ctr">
+                    <a:solidFill>
+                      <a:srgbClr val="ECF1F6"/>
+                    </a:solidFill>
+                  </a:tcPr>
+                </a:tc>
+                <a:tc>
+                  <a:txBody>
+                    <a:bodyPr/>
+                    <a:lstStyle/>
+                    <a:p>
+                      <a:pPr algn="ctr"/>
+                      <a:r>
+                        <a:rPr sz="1150" b="0">
+                          <a:solidFill>
+                            <a:srgbClr val="2B2B2B"/>
+                          </a:solidFill>
+                          <a:latin typeface="Calibri"/>
+                        </a:rPr>
+                        <a:t>0.00576</a:t>
+                      </a:r>
+                    </a:p>
+                  </a:txBody>
+                  <a:tcPr marL="73152" marR="45720" marT="18288" marB="18288" anchor="ctr">
+                    <a:solidFill>
+                      <a:srgbClr val="ECF1F6"/>
+                    </a:solidFill>
+                  </a:tcPr>
+                </a:tc>
+                <a:tc>
+                  <a:txBody>
+                    <a:bodyPr/>
+                    <a:lstStyle/>
+                    <a:p>
+                      <a:pPr algn="ctr"/>
+                      <a:r>
+                        <a:rPr sz="1150" b="0">
+                          <a:solidFill>
+                            <a:srgbClr val="2B2B2B"/>
+                          </a:solidFill>
+                          <a:latin typeface="Calibri"/>
+                        </a:rPr>
+                        <a:t>1.5569</a:t>
+                      </a:r>
+                    </a:p>
+                  </a:txBody>
+                  <a:tcPr marL="73152" marR="45720" marT="18288" marB="18288" anchor="ctr">
+                    <a:solidFill>
+                      <a:srgbClr val="ECF1F6"/>
+                    </a:solidFill>
+                  </a:tcPr>
+                </a:tc>
+              </a:tr>
+              <a:tr h="426720">
+                <a:tc>
+                  <a:txBody>
+                    <a:bodyPr/>
+                    <a:lstStyle/>
+                    <a:p>
+                      <a:pPr algn="l"/>
+                      <a:r>
+                        <a:rPr sz="1150" b="0">
+                          <a:solidFill>
+                            <a:srgbClr val="2B2B2B"/>
+                          </a:solidFill>
+                          <a:latin typeface="Calibri"/>
+                        </a:rPr>
+                        <a:t>EWMA(0.94)</a:t>
+                      </a:r>
+                    </a:p>
+                  </a:txBody>
+                  <a:tcPr marL="73152" marR="45720" marT="18288" marB="18288" anchor="ctr">
+                    <a:solidFill>
+                      <a:srgbClr val="FFFFFF"/>
+                    </a:solidFill>
+                  </a:tcPr>
+                </a:tc>
+                <a:tc>
+                  <a:txBody>
+                    <a:bodyPr/>
+                    <a:lstStyle/>
+                    <a:p>
+                      <a:pPr algn="ctr"/>
+                      <a:r>
+                        <a:rPr sz="1150" b="0">
+                          <a:solidFill>
+                            <a:srgbClr val="2B2B2B"/>
+                          </a:solidFill>
+                          <a:latin typeface="Calibri"/>
+                        </a:rPr>
+                        <a:t>0.00750</a:t>
+                      </a:r>
+                    </a:p>
+                  </a:txBody>
+                  <a:tcPr marL="73152" marR="45720" marT="18288" marB="18288" anchor="ctr">
+                    <a:solidFill>
+                      <a:srgbClr val="FFFFFF"/>
+                    </a:solidFill>
+                  </a:tcPr>
+                </a:tc>
+                <a:tc>
+                  <a:txBody>
+                    <a:bodyPr/>
+                    <a:lstStyle/>
+                    <a:p>
+                      <a:pPr algn="ctr"/>
+                      <a:r>
+                        <a:rPr sz="1150" b="0">
+                          <a:solidFill>
+                            <a:srgbClr val="2B2B2B"/>
+                          </a:solidFill>
+                          <a:latin typeface="Calibri"/>
+                        </a:rPr>
+                        <a:t>0.00573</a:t>
+                      </a:r>
+                    </a:p>
+                  </a:txBody>
+                  <a:tcPr marL="73152" marR="45720" marT="18288" marB="18288" anchor="ctr">
+                    <a:solidFill>
+                      <a:srgbClr val="FFFFFF"/>
+                    </a:solidFill>
+                  </a:tcPr>
+                </a:tc>
+                <a:tc>
+                  <a:txBody>
+                    <a:bodyPr/>
+                    <a:lstStyle/>
+                    <a:p>
+                      <a:pPr algn="ctr"/>
+                      <a:r>
+                        <a:rPr sz="1150" b="0">
+                          <a:solidFill>
+                            <a:srgbClr val="2B2B2B"/>
+                          </a:solidFill>
+                          <a:latin typeface="Calibri"/>
+                        </a:rPr>
+                        <a:t>1.5814</a:t>
+                      </a:r>
+                    </a:p>
+                  </a:txBody>
+                  <a:tcPr marL="73152" marR="45720" marT="18288" marB="18288" anchor="ctr">
+                    <a:solidFill>
+                      <a:srgbClr val="FFFFFF"/>
+                    </a:solidFill>
+                  </a:tcPr>
+                </a:tc>
+              </a:tr>
+              <a:tr h="426720">
+                <a:tc>
+                  <a:txBody>
+                    <a:bodyPr/>
+                    <a:lstStyle/>
+                    <a:p>
+                      <a:pPr algn="l"/>
+                      <a:r>
+                        <a:rPr sz="1150" b="0">
+                          <a:solidFill>
+                            <a:srgbClr val="2B2B2B"/>
+                          </a:solidFill>
+                          <a:latin typeface="Calibri"/>
+                        </a:rPr>
+                        <a:t>XGBoost</a:t>
+                      </a:r>
+                    </a:p>
+                  </a:txBody>
+                  <a:tcPr marL="73152" marR="45720" marT="18288" marB="18288" anchor="ctr">
+                    <a:solidFill>
+                      <a:srgbClr val="ECF1F6"/>
+                    </a:solidFill>
+                  </a:tcPr>
+                </a:tc>
+                <a:tc>
+                  <a:txBody>
+                    <a:bodyPr/>
+                    <a:lstStyle/>
+                    <a:p>
+                      <a:pPr algn="ctr"/>
+                      <a:r>
+                        <a:rPr sz="1150" b="0">
+                          <a:solidFill>
+                            <a:srgbClr val="2B2B2B"/>
+                          </a:solidFill>
+                          <a:latin typeface="Calibri"/>
+                        </a:rPr>
+                        <a:t>0.00691</a:t>
+                      </a:r>
+                    </a:p>
+                  </a:txBody>
+                  <a:tcPr marL="73152" marR="45720" marT="18288" marB="18288" anchor="ctr">
+                    <a:solidFill>
+                      <a:srgbClr val="ECF1F6"/>
+                    </a:solidFill>
+                  </a:tcPr>
+                </a:tc>
+                <a:tc>
+                  <a:txBody>
+                    <a:bodyPr/>
+                    <a:lstStyle/>
+                    <a:p>
+                      <a:pPr algn="ctr"/>
+                      <a:r>
+                        <a:rPr sz="1150" b="0">
+                          <a:solidFill>
+                            <a:srgbClr val="2B2B2B"/>
+                          </a:solidFill>
+                          <a:latin typeface="Calibri"/>
+                        </a:rPr>
+                        <a:t>0.00496</a:t>
+                      </a:r>
+                    </a:p>
+                  </a:txBody>
+                  <a:tcPr marL="73152" marR="45720" marT="18288" marB="18288" anchor="ctr">
+                    <a:solidFill>
+                      <a:srgbClr val="ECF1F6"/>
+                    </a:solidFill>
+                  </a:tcPr>
+                </a:tc>
+                <a:tc>
+                  <a:txBody>
+                    <a:bodyPr/>
+                    <a:lstStyle/>
+                    <a:p>
+                      <a:pPr algn="ctr"/>
+                      <a:r>
+                        <a:rPr sz="1150" b="0">
+                          <a:solidFill>
+                            <a:srgbClr val="2B2B2B"/>
+                          </a:solidFill>
+                          <a:latin typeface="Calibri"/>
+                        </a:rPr>
+                        <a:t>1.5911</a:t>
+                      </a:r>
+                    </a:p>
+                  </a:txBody>
+                  <a:tcPr marL="73152" marR="45720" marT="18288" marB="18288" anchor="ctr">
+                    <a:solidFill>
+                      <a:srgbClr val="ECF1F6"/>
+                    </a:solidFill>
+                  </a:tcPr>
+                </a:tc>
+              </a:tr>
+              <a:tr h="426720">
+                <a:tc>
+                  <a:txBody>
+                    <a:bodyPr/>
+                    <a:lstStyle/>
+                    <a:p>
+                      <a:pPr algn="l"/>
+                      <a:r>
+                        <a:rPr sz="1150" b="0">
+                          <a:solidFill>
+                            <a:srgbClr val="2B2B2B"/>
+                          </a:solidFill>
+                          <a:latin typeface="Calibri"/>
+                        </a:rPr>
+                        <a:t>Rolling(21)</a:t>
+                      </a:r>
+                    </a:p>
+                  </a:txBody>
+                  <a:tcPr marL="73152" marR="45720" marT="18288" marB="18288" anchor="ctr">
+                    <a:solidFill>
+                      <a:srgbClr val="FFFFFF"/>
+                    </a:solidFill>
+                  </a:tcPr>
+                </a:tc>
+                <a:tc>
+                  <a:txBody>
+                    <a:bodyPr/>
+                    <a:lstStyle/>
+                    <a:p>
+                      <a:pPr algn="ctr"/>
+                      <a:r>
+                        <a:rPr sz="1150" b="0">
+                          <a:solidFill>
+                            <a:srgbClr val="2B2B2B"/>
+                          </a:solidFill>
+                          <a:latin typeface="Calibri"/>
+                        </a:rPr>
+                        <a:t>0.00762</a:t>
+                      </a:r>
+                    </a:p>
+                  </a:txBody>
+                  <a:tcPr marL="73152" marR="45720" marT="18288" marB="18288" anchor="ctr">
+                    <a:solidFill>
+                      <a:srgbClr val="FFFFFF"/>
+                    </a:solidFill>
+                  </a:tcPr>
+                </a:tc>
+                <a:tc>
+                  <a:txBody>
+                    <a:bodyPr/>
+                    <a:lstStyle/>
+                    <a:p>
+                      <a:pPr algn="ctr"/>
+                      <a:r>
+                        <a:rPr sz="1150" b="0">
+                          <a:solidFill>
+                            <a:srgbClr val="2B2B2B"/>
+                          </a:solidFill>
+                          <a:latin typeface="Calibri"/>
+                        </a:rPr>
+                        <a:t>0.00571</a:t>
+                      </a:r>
+                    </a:p>
+                  </a:txBody>
+                  <a:tcPr marL="73152" marR="45720" marT="18288" marB="18288" anchor="ctr">
+                    <a:solidFill>
+                      <a:srgbClr val="FFFFFF"/>
+                    </a:solidFill>
+                  </a:tcPr>
+                </a:tc>
+                <a:tc>
+                  <a:txBody>
+                    <a:bodyPr/>
+                    <a:lstStyle/>
+                    <a:p>
+                      <a:pPr algn="ctr"/>
+                      <a:r>
+                        <a:rPr sz="1150" b="0">
+                          <a:solidFill>
+                            <a:srgbClr val="2B2B2B"/>
+                          </a:solidFill>
+                          <a:latin typeface="Calibri"/>
+                        </a:rPr>
+                        <a:t>1.6344</a:t>
                       </a:r>
                     </a:p>
                   </a:txBody>
@@ -9172,7 +9197,7 @@
                           </a:solidFill>
                           <a:latin typeface="Calibri"/>
                         </a:rPr>
-                        <a:t>0.01114</a:t>
+                        <a:t>0.00951</a:t>
                       </a:r>
                     </a:p>
                   </a:txBody>
@@ -9195,7 +9220,7 @@
                           </a:solidFill>
                           <a:latin typeface="Calibri"/>
                         </a:rPr>
-                        <a:t>0.00747</a:t>
+                        <a:t>0.00672</a:t>
                       </a:r>
                     </a:p>
                   </a:txBody>
@@ -9218,7 +9243,7 @@
                           </a:solidFill>
                           <a:latin typeface="Calibri"/>
                         </a:rPr>
-                        <a:t>1192.7</a:t>
+                        <a:t>5440.5</a:t>
                       </a:r>
                     </a:p>
                   </a:txBody>
@@ -9249,8 +9274,8 @@
         </p:blipFill>
         <p:spPr>
           <a:xfrm>
-            <a:off x="6172200" y="2331720"/>
-            <a:ext cx="5486400" cy="2286000"/>
+            <a:off x="6172200" y="2344217"/>
+            <a:ext cx="5486400" cy="2261005"/>
           </a:xfrm>
           <a:prstGeom prst="rect">
             <a:avLst/>
@@ -9286,7 +9311,7 @@
                 </a:solidFill>
                 <a:latin typeface="Calibri"/>
               </a:rPr>
-              <a:t>All models track the same clusters. GARCH(1,1) wins on QLIKE; XGBoost has the best RMSE/MAE but ranks 5th on QLIKE.</a:t>
+              <a:t>All models track the same clusters. EGARCH(1,1) wins on QLIKE; the LSTM ranks 3rd, ahead of plain GARCH; the learned models take the best RMSE (LSTM) and MAE (XGBoost).</a:t>
             </a:r>
           </a:p>
         </p:txBody>

</xml_diff>